<commit_message>
Polish lesson 3 deck: tighter slide text, speaker notes
Condense long paragraphs on 22 slides to their key points and move the
full original wording into speaker notes; enlarge body type to match;
replace 教师 with 作者 where the text refers to the paper's author; add
reference research objectives for the gap-to-objective exercise in notes.

Co-Authored-By: Claude Opus 5.5 <noreply@anthropic.com>
Claude-Session: https://claude.ai/code/session_01JrHxez3pDsbdbTVBSJwUS8
</commit_message>
<xml_diff>
--- a/courses/第3课_学术论文研究背景撰写技巧.pptx
+++ b/courses/第3课_学术论文研究背景撰写技巧.pptx
@@ -1425,7 +1425,9 @@
           <a:p>
             <a:r>
               <a:rPr lang="en-US" dirty="0"/>
-              <a:t/>
+              <a:t>【原文要点，供讲解】
+在修改开篇时，作者应该调整语言，使研究的问题显得更加紧迫和有意义。例如，可以引用最新的数据或社会事件，说明研究的现实关联性。这样能够增强文章的吸引力，让读者感到研究的紧迫性。
+为了突出研究的重要性和紧迫性，作者可以在开篇中引用最新数据或社会事件。这些数据和事件可以作为研究的背景，说明研究的现实意义。通过引用具体的数据和事件，文章的开篇将更具说服力。</a:t>
             </a:r>
             <a:endParaRPr lang="en-US" dirty="0"/>
           </a:p>
@@ -1513,7 +1515,9 @@
           <a:p>
             <a:r>
               <a:rPr lang="en-US" dirty="0"/>
-              <a:t/>
+              <a:t>【原文要点，供讲解】
+在修改开篇时，作者应该明确展示研究的创新性和独特视角。这可以通过对比已有研究，指出本研究的新颖之处，或者提出新的理论观点来实现。强调研究的独特贡献有助于提升文章的学术价值。
+在强调研究的独特贡献时，作者还需要引导读者理解研究的价值。这包括说明研究如何填补学术空白，或者如何解决实际问题。通过明确展示研究的价值，读者可以更好地认识到文章的重要性。</a:t>
             </a:r>
             <a:endParaRPr lang="en-US" dirty="0"/>
           </a:p>
@@ -1601,7 +1605,9 @@
           <a:p>
             <a:r>
               <a:rPr lang="en-US" dirty="0"/>
-              <a:t/>
+              <a:t>【原文要点，供讲解】
+在文章的结论部分，作者需要重申核心论点，确保读者清晰理解文章的成果。这有助于巩固读者对文章主要观点的记忆，使文章的结论更加深刻。
+在结论部分，作者应该简要总结研究的主要发现。这应该包括研究的关键结果和结论，以及这些结果的意义。通过简洁明了的总结，读者可以快速把握文章的核心内容。</a:t>
             </a:r>
             <a:endParaRPr lang="en-US" dirty="0"/>
           </a:p>
@@ -1777,7 +1783,9 @@
           <a:p>
             <a:r>
               <a:rPr lang="en-US" dirty="0"/>
-              <a:t/>
+              <a:t>【原文要点，供讲解】
+一个好的标题应该能够精准传达文章的主题和研究对象。作者应该避免使用冗长或复杂的语言，而是要力求简洁明了。这样不仅能够吸引读者的注意力，还能够帮助读者快速理解文章的内容。
+在修改标题时，作者应该避免使用冗长或复杂的语言。冗长的标题可能会让读者感到困惑，甚至失去阅读的兴趣。因此，作者应该力求标题的简洁性，使其一目了然。</a:t>
             </a:r>
             <a:endParaRPr lang="en-US" dirty="0"/>
           </a:p>
@@ -1865,7 +1873,9 @@
           <a:p>
             <a:r>
               <a:rPr lang="en-US" dirty="0"/>
-              <a:t/>
+              <a:t>【原文要点，供讲解】
+标题应该包含研究的核心内容或关键词，使读者一目了然地了解文章的研究方向。这有助于提高文章的可读性，让读者在阅读全文之前就对文章的主题有一个大致的了解。
+在修改标题时，作者应该确保标题能够概括文章的重点，包括研究对象、方法或发现。这样不仅能够吸引读者的注意力，还能够帮助读者快速定位文章的核心内容。</a:t>
             </a:r>
             <a:endParaRPr lang="en-US" dirty="0"/>
           </a:p>
@@ -1953,7 +1963,9 @@
           <a:p>
             <a:r>
               <a:rPr lang="en-US" dirty="0"/>
-              <a:t/>
+              <a:t>【原文要点，供讲解】
+为了增加标题的创新性，作者可以在标题中加入能够展示创新性的词语。例如，如果研究涉及新方法或新理论，可以在标题中加以强调。这样的标题能够吸引读者的兴趣，使他们更愿意阅读全文。
+在修改标题时，作者应该考虑如何吸引读者的兴趣。一个具有创新性的标题能够激发读者的好奇心，促使他们进一步探索文章的内容。</a:t>
             </a:r>
             <a:endParaRPr lang="en-US" dirty="0"/>
           </a:p>
@@ -2041,7 +2053,9 @@
           <a:p>
             <a:r>
               <a:rPr lang="en-US" dirty="0"/>
-              <a:t/>
+              <a:t>【原文要点，供讲解】
+在修改标题时，作者应该考虑读者的检索需求。标题应包含易于检索的关键词，使文章在学术数据库中更易被找到。这样不仅能够提高文章的引用率，还能够增加读者的阅读和引用可能性。
+为了提高文章的可发现性，作者应该在标题中包含易于检索的关键词。这些关键词应该与研究的主题和内容紧密相关，以便读者在搜索时能够快速找到相关文章。</a:t>
             </a:r>
             <a:endParaRPr lang="en-US" dirty="0"/>
           </a:p>
@@ -2569,7 +2583,11 @@
           <a:p>
             <a:r>
               <a:rPr lang="en-US" dirty="0"/>
-              <a:t/>
+              <a:t>【原文要点，供讲解】
+研究背景主要包括问题的提出、国内外研究现状、研究意义和目的等几个部分，它们共同构成了研究背景的框架。
+背景信息与研究主题紧密相连，为研究的展开提供了必要的背景支持和理论依据。
+研究背景的逻辑框架应清晰明确，从问题的提出到研究目的的设定，形成一个严密的结构体系。
+研究背景的写作应注重逻辑性、条理性和准确性，避免冗余和泛泛而谈，以确保读者能够快速理解研究背景。</a:t>
             </a:r>
             <a:endParaRPr lang="en-US" dirty="0"/>
           </a:p>
@@ -2657,7 +2675,11 @@
           <a:p>
             <a:r>
               <a:rPr lang="en-US" dirty="0"/>
-              <a:t/>
+              <a:t>【原文要点，供讲解】
+国内外在该领域的研究已经取得了一系列进展，例如，国外研究者在理论模型构建方面有深入探索，而国内研究者则在实证分析方面取得了丰富成果。这些研究为我们提供了宝贵的基础资料，但也存在一定的局限性，需要进一步整合和创新。
+当前研究领域内，一些热点问题引起了广泛关注，如技术的可持续发展、环境政策的效应评估等。这些问题直接关系到社会经济的可持续发展，因此成为学术界和政策制定者关注的焦点。
+尽管研究取得了一定成果，但仍然存在数据质量、研究方法适用性等方面的不足和挑战。这些不足限制了研究的深度和广度，需要我们采取更加科学的方法和手段来解决。
+随着科技进步和社会发展，研究领域呈现出一些新的趋势，例如大数据分析、跨学科研究等。这些趋势为未来研究提供了新的思路和方向。</a:t>
             </a:r>
             <a:endParaRPr lang="en-US" dirty="0"/>
           </a:p>
@@ -2745,7 +2767,11 @@
           <a:p>
             <a:r>
               <a:rPr lang="en-US" dirty="0"/>
-              <a:t/>
+              <a:t>【原文要点，供讲解】
+从学术角度来看，本研究有助于丰富和完善相关理论体系，为后续研究提供新的视角和理论支撑，推动学科的发展。
+本研究在现有研究的基础上，进一步探讨了某些尚未充分研究的问题，对现有研究成果进行了补充和完善。
+本研究的成果可直接应用于解决现实问题，如提高政策制定的科学性、促进产业的可持续发展等，具有显著的实际应用价值。
+本研究的发现和结论为未来研究提供了方向和指导，有助于学术界更好地规划后续研究工作。</a:t>
             </a:r>
             <a:endParaRPr lang="en-US" dirty="0"/>
           </a:p>
@@ -2833,7 +2859,11 @@
           <a:p>
             <a:r>
               <a:rPr lang="en-US" dirty="0"/>
-              <a:t/>
+              <a:t>【原文要点，供讲解】
+本研究的目标是系统地分析某一领域的问题，探索其内在规律，并提出相应的解决方案，以期促进该领域的发展。
+研究内容主要包括对该领域现状的分析、对热点问题的探讨、对研究方法的创新以及对未来趋势的预测等。
+本研究采用了文献分析、实证研究、案例分析等多种研究方法，以确保研究的全面性和深入性。
+预期通过本研究，能够提出一些有价值的观点和结论，为学术界和政策制定者提供参考。</a:t>
             </a:r>
             <a:endParaRPr lang="en-US" dirty="0"/>
           </a:p>
@@ -3097,7 +3127,9 @@
           <a:p>
             <a:r>
               <a:rPr lang="en-US" dirty="0"/>
-              <a:t/>
+              <a:t>【参考研究目标，供讲解】
+· 校园文化空间：梳理校园文化空间的流线与场所营造策略，提升学生使用时的方向感与场所感，从而增强学生的文化认同感。
+· 适老智能家居：简化智能家居设备的交互设计，降低老年用户的操作难度，提升其对智能设备的使用意愿与依赖度。</a:t>
             </a:r>
             <a:endParaRPr lang="en-US" dirty="0"/>
           </a:p>
@@ -3361,7 +3393,11 @@
           <a:p>
             <a:r>
               <a:rPr lang="en-US" dirty="0"/>
-              <a:t/>
+              <a:t>【原文要点，供讲解】
+如何从图书馆、数据库等渠道获取相关文献，包括书籍、期刊文章、会议论文等。搜集过程中要注意文献的权威性、时效性和相关性，确保所选文献对研究领域有实质性的贡献。
+实证数据是研究背景中不可或缺的通过实验、调查问卷、统计数据等方式收集数据。在获取数据时，要注重数据的真实性和可靠性，避免数据造假或误用。
+如何联系专家、设计访谈提纲，并从中提取有价值的信息。此外，调研过程中要注意保持客观和尊重，确保信息的准确性。
+筛选和评估网络资源，包括学术论文、专业网站、在线数据库等。同时，要注意识别网络上的不实信息和伪科学内容，避免误导。</a:t>
             </a:r>
             <a:endParaRPr lang="en-US" dirty="0"/>
           </a:p>
@@ -3449,7 +3485,11 @@
           <a:p>
             <a:r>
               <a:rPr lang="en-US" dirty="0"/>
-              <a:t/>
+              <a:t>【原文要点，供讲解】
+按照类型、主题、来源等分类。分类工作有助于后续的分析和处理，使资料更加条理化。
+分析资料与研究主题的相关性，筛选出与研究密切相关的资料，剔除无关或弱相关的资料。相关性分析有助于提高研究的针对性和有效性。
+评估资料的可信度，包括作者资质、出版机构、引用频次等。通过评估，确保使用的是可靠和权威的资料，增强研究的可信度。
+将搜集到的资料综合运用到研究背景中，包括资料的引用、整合和对比分析等。综合运用资料可以使研究背景更加丰富和立体。</a:t>
             </a:r>
             <a:endParaRPr lang="en-US" dirty="0"/>
           </a:p>
@@ -3713,7 +3753,8 @@
           <a:p>
             <a:r>
               <a:rPr lang="en-US" dirty="0"/>
-              <a:t/>
+              <a:t>【原文要点，供讲解】
+在撰写研究背景时，需要梳理出一条贯穿全文的主线，这条主线通常围绕研究的核心问题展开。通过梳理主线，作者可以更好地引导读者理解研究的重要性，以及研究内容与主题之间的紧密联系。</a:t>
             </a:r>
             <a:endParaRPr lang="en-US" dirty="0"/>
           </a:p>
@@ -3801,7 +3842,11 @@
           <a:p>
             <a:r>
               <a:rPr lang="en-US" dirty="0"/>
-              <a:t/>
+              <a:t>【原文要点，供讲解】
+在研究背景中，信息分类是指将收集到的资料按照类型、来源或重要性进行分类整理。这种分类有助于作者清晰地识别和组织信息，使背景内容更加有条理性和系统性。
+条理清晰度是指研究背景的表述是否清晰易懂，是否能够使作者一目了然地理解研究背景的全貌。这需要作者在撰写时注重语言的简练、逻辑的清晰，避免冗余和模糊的表述。
+连贯性是指研究背景中的信息、观点和论证是否形成一个连续、统一的整体。作者应当确保各部分内容相互关联，相互支撑，避免出现跳跃和断裂，使背景内容更加协调一致。
+易读性是指研究背景是否易于阅读和理解。作者应当在撰写时考虑到读者的背景知识，使用恰当的术语和表达方式，使内容既专业又易于接受，以便于读者快速把握研究背景的核心信息。</a:t>
             </a:r>
             <a:endParaRPr lang="en-US" dirty="0"/>
           </a:p>
@@ -4065,7 +4110,8 @@
           <a:p>
             <a:r>
               <a:rPr lang="en-US" dirty="0"/>
-              <a:t/>
+              <a:t>【原文要点，供讲解】
+图表类型的选择应基于数据的特点和需要展示的信息。例如，对于趋势分析，折线图可能是最佳选择；而对于比较不同组的数据，条形图或饼图可能更为合适。</a:t>
             </a:r>
             <a:endParaRPr lang="en-US" dirty="0"/>
           </a:p>
@@ -4241,7 +4287,9 @@
           <a:p>
             <a:r>
               <a:rPr lang="en-US" dirty="0"/>
-              <a:t/>
+              <a:t>【原文要点，供讲解】
+文章的开篇段落是吸引读者的关键所在。它就像是一扇门，透过这扇门，读者可以窥见文章的精彩内容。一个引人入胜的开篇能够激发读者的好奇心，促使他们继续阅读下去。这就要求作者在撰写开篇时，要力求创新，用生动有趣的语言，或者提出一个引人深思的问题，来吸引读者的注意力。
+在撰写开篇段落时，作者可以采用多种技巧。比如，可以引用一个相关的故事或者案例，让读者产生共鸣；或者提出一个有争议性的观点，引发读者的思考。此外，开篇段落还应该简洁明了，避免冗长的叙述，以免让读者感到疲惫。</a:t>
             </a:r>
             <a:endParaRPr lang="en-US" dirty="0"/>
           </a:p>
@@ -4329,7 +4377,9 @@
           <a:p>
             <a:r>
               <a:rPr lang="en-US" dirty="0"/>
-              <a:t/>
+              <a:t>【原文要点，供讲解】
+在文章的开篇部分，引入研究背景是非常重要的。这有助于读者理解研究的起点和研究的必要性。研究背景的引入应该简洁明了，避免过多的细节，而是要突出研究的核心问题和研究的重要性。
+在开篇部分，作者需要明确提出研究的问题或假设。这些问题或假设应该是具体且具有针对性的，能够引导读者理解研究的方向和目的。通过提出明确的研究问题，读者可以更好地跟随作者的思路，理解文章的核心内容。</a:t>
             </a:r>
             <a:endParaRPr lang="en-US" dirty="0"/>
           </a:p>
@@ -4417,7 +4467,9 @@
           <a:p>
             <a:r>
               <a:rPr lang="en-US" dirty="0"/>
-              <a:t/>
+              <a:t>【原文要点，供讲解】
+在文章的开篇部分，作者需要展示研究的创新性或独特视角。这可以通过对比已有研究，指出本研究的新颖之处，或者提出新的理论观点来实现。展示研究的创新性有助于增强文章的学术价值，吸引读者的关注。
+强调研究的独特贡献是开篇部分的重要任务。作者应该明确指出本研究如何填补学术空白，或者如何解决实际问题。这样不仅能够体现研究的价值，还能够激发读者的阅读兴趣。</a:t>
             </a:r>
             <a:endParaRPr lang="en-US" dirty="0"/>
           </a:p>
@@ -4505,7 +4557,9 @@
           <a:p>
             <a:r>
               <a:rPr lang="en-US" dirty="0"/>
-              <a:t/>
+              <a:t>【原文要点，供讲解】
+在开篇部分，作者应该为读者提供清晰的阅读框架，概述文章的主要内容。这包括介绍文章的研究方法、主要观点和结论。通过概述文章结构，读者可以更好地把握文章的脉络，提高阅读效率。
+开篇部分不仅要提供阅读框架，还要引导读者进入文章的核心内容。这可以通过提出问题、设置悬念或者引用相关研究来实现。通过巧妙地引导，读者可以更加投入地阅读文章，理解作者的意图。</a:t>
             </a:r>
             <a:endParaRPr lang="en-US" dirty="0"/>
           </a:p>
@@ -4681,7 +4735,9 @@
           <a:p>
             <a:r>
               <a:rPr lang="en-US" dirty="0"/>
-              <a:t/>
+              <a:t>【原文要点，供讲解】
+为了提升文章的吸引力，作者需要重新审视开篇段落。这包括检查语言是否生动有趣，是否能够激发读者的好奇心。如果开篇段落过于平淡，作者可以考虑增加一些生动的案例、引用或者提出具有争议性的问题。
+在修改开篇时，作者可以增加生动语言，使文章更具吸引力。同时，提出具有争议性的问题也是一个有效的方法。这样的问题能够引发读者的思考，激发他们的阅读兴趣。</a:t>
             </a:r>
             <a:endParaRPr lang="en-US" dirty="0"/>
           </a:p>
@@ -5607,7 +5663,7 @@
       </p:sp>
       <p:sp>
         <p:nvSpPr>
-          <p:cNvPr id="9" name="Shape 7"/>
+          <p:cNvPr id="10" name="Shape 7"/>
           <p:cNvSpPr/>
           <p:nvPr/>
         </p:nvSpPr>
@@ -5627,7 +5683,7 @@
       </p:sp>
       <p:sp>
         <p:nvSpPr>
-          <p:cNvPr id="10" name="Text 8"/>
+          <p:cNvPr id="11" name="Text 8"/>
           <p:cNvSpPr txBox="1"/>
           <p:nvPr/>
         </p:nvSpPr>
@@ -5666,7 +5722,7 @@
       </p:sp>
       <p:sp>
         <p:nvSpPr>
-          <p:cNvPr id="11" name="Text 9"/>
+          <p:cNvPr id="12" name="Text 9"/>
           <p:cNvSpPr txBox="1"/>
           <p:nvPr/>
         </p:nvSpPr>
@@ -5705,7 +5761,7 @@
       </p:sp>
       <p:sp>
         <p:nvSpPr>
-          <p:cNvPr id="12" name="Text 10"/>
+          <p:cNvPr id="13" name="Text 10"/>
           <p:cNvSpPr txBox="1"/>
           <p:nvPr/>
         </p:nvSpPr>
@@ -5726,12 +5782,12 @@
           <a:p>
             <a:pPr indent="0" marL="0">
               <a:lnSpc>
-                <a:spcPct val="145000"/>
+                <a:spcPct val="150000"/>
               </a:lnSpc>
               <a:buNone/>
             </a:pPr>
             <a:r>
-              <a:rPr lang="en-US" sz="1200" dirty="0">
+              <a:rPr lang="en-US" sz="1600" dirty="0">
                 <a:solidFill>
                   <a:srgbClr val="2D2D2D"/>
                 </a:solidFill>
@@ -5739,15 +5795,15 @@
                 <a:ea typeface="Microsoft YaHei" pitchFamily="34" charset="-122"/>
                 <a:cs typeface="Microsoft YaHei" pitchFamily="34" charset="-120"/>
               </a:rPr>
-              <a:t>在修改开篇时，作者应该调整语言，使研究的问题显得更加紧迫和有意义。例如，可以引用最新的数据或社会事件，说明研究的现实关联性。这样能够增强文章的吸引力，让读者感到研究的紧迫性。</a:t>
-            </a:r>
-            <a:endParaRPr lang="en-US" sz="1200" dirty="0"/>
-          </a:p>
-        </p:txBody>
-      </p:sp>
-      <p:sp>
-        <p:nvSpPr>
-          <p:cNvPr id="13" name="Shape 11"/>
+              <a:t>让研究问题显得紧迫而有意义，说明研究的现实关联性，让读者感到研究刻不容缓。</a:t>
+            </a:r>
+            <a:endParaRPr lang="en-US" sz="1600" dirty="0"/>
+          </a:p>
+        </p:txBody>
+      </p:sp>
+      <p:sp>
+        <p:nvSpPr>
+          <p:cNvPr id="14" name="Shape 11"/>
           <p:cNvSpPr/>
           <p:nvPr/>
         </p:nvSpPr>
@@ -5767,7 +5823,7 @@
       </p:sp>
       <p:sp>
         <p:nvSpPr>
-          <p:cNvPr id="14" name="Text 12"/>
+          <p:cNvPr id="15" name="Text 12"/>
           <p:cNvSpPr txBox="1"/>
           <p:nvPr/>
         </p:nvSpPr>
@@ -5806,7 +5862,7 @@
       </p:sp>
       <p:sp>
         <p:nvSpPr>
-          <p:cNvPr id="15" name="Text 13"/>
+          <p:cNvPr id="16" name="Text 13"/>
           <p:cNvSpPr txBox="1"/>
           <p:nvPr/>
         </p:nvSpPr>
@@ -5845,7 +5901,7 @@
       </p:sp>
       <p:sp>
         <p:nvSpPr>
-          <p:cNvPr id="16" name="Text 14"/>
+          <p:cNvPr id="17" name="Text 14"/>
           <p:cNvSpPr txBox="1"/>
           <p:nvPr/>
         </p:nvSpPr>
@@ -5866,12 +5922,12 @@
           <a:p>
             <a:pPr indent="0" marL="0">
               <a:lnSpc>
-                <a:spcPct val="145000"/>
+                <a:spcPct val="150000"/>
               </a:lnSpc>
               <a:buNone/>
             </a:pPr>
             <a:r>
-              <a:rPr lang="en-US" sz="1200" dirty="0">
+              <a:rPr lang="en-US" sz="1600" dirty="0">
                 <a:solidFill>
                   <a:srgbClr val="2D2D2D"/>
                 </a:solidFill>
@@ -5879,9 +5935,9 @@
                 <a:ea typeface="Microsoft YaHei" pitchFamily="34" charset="-122"/>
                 <a:cs typeface="Microsoft YaHei" pitchFamily="34" charset="-120"/>
               </a:rPr>
-              <a:t>为了突出研究的重要性和紧迫性，作者可以在开篇中引用最新数据或社会事件。这些数据和事件可以作为研究的背景，说明研究的现实意义。通过引用具体的数据和事件，文章的开篇将更具说服力。</a:t>
-            </a:r>
-            <a:endParaRPr lang="en-US" sz="1200" dirty="0"/>
+              <a:t>以最新数据或社会事件作为研究背景，说明现实意义，让开篇更具说服力。</a:t>
+            </a:r>
+            <a:endParaRPr lang="en-US" sz="1600" dirty="0"/>
           </a:p>
         </p:txBody>
       </p:sp>
@@ -6156,7 +6212,7 @@
       </p:sp>
       <p:sp>
         <p:nvSpPr>
-          <p:cNvPr id="9" name="Shape 7"/>
+          <p:cNvPr id="10" name="Shape 7"/>
           <p:cNvSpPr/>
           <p:nvPr/>
         </p:nvSpPr>
@@ -6176,7 +6232,7 @@
       </p:sp>
       <p:sp>
         <p:nvSpPr>
-          <p:cNvPr id="10" name="Text 8"/>
+          <p:cNvPr id="11" name="Text 8"/>
           <p:cNvSpPr txBox="1"/>
           <p:nvPr/>
         </p:nvSpPr>
@@ -6215,7 +6271,7 @@
       </p:sp>
       <p:sp>
         <p:nvSpPr>
-          <p:cNvPr id="11" name="Text 9"/>
+          <p:cNvPr id="12" name="Text 9"/>
           <p:cNvSpPr txBox="1"/>
           <p:nvPr/>
         </p:nvSpPr>
@@ -6238,7 +6294,7 @@
               <a:buNone/>
             </a:pPr>
             <a:r>
-              <a:rPr lang="en-US" sz="1400" b="1" dirty="0">
+              <a:rPr lang="en-US" sz="1500" b="1" dirty="0">
                 <a:solidFill>
                   <a:srgbClr val="2D2D2D"/>
                 </a:solidFill>
@@ -6248,13 +6304,13 @@
               </a:rPr>
               <a:t>明确展示研究的创新性和独特视角</a:t>
             </a:r>
-            <a:endParaRPr lang="en-US" sz="1400" dirty="0"/>
-          </a:p>
-        </p:txBody>
-      </p:sp>
-      <p:sp>
-        <p:nvSpPr>
-          <p:cNvPr id="12" name="Text 10"/>
+            <a:endParaRPr lang="en-US" sz="1500" dirty="0"/>
+          </a:p>
+        </p:txBody>
+      </p:sp>
+      <p:sp>
+        <p:nvSpPr>
+          <p:cNvPr id="13" name="Text 10"/>
           <p:cNvSpPr txBox="1"/>
           <p:nvPr/>
         </p:nvSpPr>
@@ -6283,7 +6339,7 @@
               <a:buNone/>
             </a:pPr>
             <a:r>
-              <a:rPr lang="en-US" sz="1050" dirty="0">
+              <a:rPr lang="en-US" sz="1250" dirty="0">
                 <a:solidFill>
                   <a:srgbClr val="2D2D2D"/>
                 </a:solidFill>
@@ -6291,15 +6347,15 @@
                 <a:ea typeface="Microsoft YaHei" pitchFamily="34" charset="-122"/>
                 <a:cs typeface="Microsoft YaHei" pitchFamily="34" charset="-120"/>
               </a:rPr>
-              <a:t>在修改开篇时，作者应该明确展示研究的创新性和独特视角。这可以通过对比已有研究，指出本研究的新颖之处，或者提出新的理论观点来实现。强调研究的独特贡献有助于提升文章的学术价值。</a:t>
-            </a:r>
-            <a:endParaRPr lang="en-US" sz="1050" dirty="0"/>
-          </a:p>
-        </p:txBody>
-      </p:sp>
-      <p:sp>
-        <p:nvSpPr>
-          <p:cNvPr id="13" name="Shape 11"/>
+              <a:t>对比已有研究、指出新颖之处，或提出新的理论观点，提升文章的学术价值。</a:t>
+            </a:r>
+            <a:endParaRPr lang="en-US" sz="1250" dirty="0"/>
+          </a:p>
+        </p:txBody>
+      </p:sp>
+      <p:sp>
+        <p:nvSpPr>
+          <p:cNvPr id="14" name="Shape 11"/>
           <p:cNvSpPr/>
           <p:nvPr/>
         </p:nvSpPr>
@@ -6319,7 +6375,7 @@
       </p:sp>
       <p:sp>
         <p:nvSpPr>
-          <p:cNvPr id="14" name="Text 12"/>
+          <p:cNvPr id="15" name="Text 12"/>
           <p:cNvSpPr txBox="1"/>
           <p:nvPr/>
         </p:nvSpPr>
@@ -6358,7 +6414,7 @@
       </p:sp>
       <p:sp>
         <p:nvSpPr>
-          <p:cNvPr id="15" name="Text 13"/>
+          <p:cNvPr id="16" name="Text 13"/>
           <p:cNvSpPr txBox="1"/>
           <p:nvPr/>
         </p:nvSpPr>
@@ -6381,7 +6437,7 @@
               <a:buNone/>
             </a:pPr>
             <a:r>
-              <a:rPr lang="en-US" sz="1400" b="1" dirty="0">
+              <a:rPr lang="en-US" sz="1500" b="1" dirty="0">
                 <a:solidFill>
                   <a:srgbClr val="FFFFFF"/>
                 </a:solidFill>
@@ -6391,13 +6447,13 @@
               </a:rPr>
               <a:t>引导读者理解研究的价值</a:t>
             </a:r>
-            <a:endParaRPr lang="en-US" sz="1400" dirty="0"/>
-          </a:p>
-        </p:txBody>
-      </p:sp>
-      <p:sp>
-        <p:nvSpPr>
-          <p:cNvPr id="16" name="Text 14"/>
+            <a:endParaRPr lang="en-US" sz="1500" dirty="0"/>
+          </a:p>
+        </p:txBody>
+      </p:sp>
+      <p:sp>
+        <p:nvSpPr>
+          <p:cNvPr id="17" name="Text 14"/>
           <p:cNvSpPr txBox="1"/>
           <p:nvPr/>
         </p:nvSpPr>
@@ -6426,7 +6482,7 @@
               <a:buNone/>
             </a:pPr>
             <a:r>
-              <a:rPr lang="en-US" sz="1050" dirty="0">
+              <a:rPr lang="en-US" sz="1250" dirty="0">
                 <a:solidFill>
                   <a:srgbClr val="FFFFFF"/>
                 </a:solidFill>
@@ -6434,15 +6490,15 @@
                 <a:ea typeface="Microsoft YaHei" pitchFamily="34" charset="-122"/>
                 <a:cs typeface="Microsoft YaHei" pitchFamily="34" charset="-120"/>
               </a:rPr>
-              <a:t>在强调研究的独特贡献时，作者还需要引导读者理解研究的价值。这包括说明研究如何填补学术空白，或者如何解决实际问题。通过明确展示研究的价值，读者可以更好地认识到文章的重要性。</a:t>
-            </a:r>
-            <a:endParaRPr lang="en-US" sz="1050" dirty="0"/>
-          </a:p>
-        </p:txBody>
-      </p:sp>
-      <p:sp>
-        <p:nvSpPr>
-          <p:cNvPr id="17" name="Shape 15"/>
+              <a:t>说明研究如何填补学术空白或解决实际问题，让读者认识到文章的重要性。</a:t>
+            </a:r>
+            <a:endParaRPr lang="en-US" sz="1250" dirty="0"/>
+          </a:p>
+        </p:txBody>
+      </p:sp>
+      <p:sp>
+        <p:nvSpPr>
+          <p:cNvPr id="18" name="Shape 15"/>
           <p:cNvSpPr/>
           <p:nvPr/>
         </p:nvSpPr>
@@ -6462,7 +6518,7 @@
       </p:sp>
       <p:sp>
         <p:nvSpPr>
-          <p:cNvPr id="18" name="Text 16"/>
+          <p:cNvPr id="19" name="Text 16"/>
           <p:cNvSpPr txBox="1"/>
           <p:nvPr/>
         </p:nvSpPr>
@@ -6501,7 +6557,7 @@
       </p:sp>
       <p:sp>
         <p:nvSpPr>
-          <p:cNvPr id="19" name="Shape 17"/>
+          <p:cNvPr id="20" name="Shape 17"/>
           <p:cNvSpPr/>
           <p:nvPr/>
         </p:nvSpPr>
@@ -6521,7 +6577,7 @@
       </p:sp>
       <p:sp>
         <p:nvSpPr>
-          <p:cNvPr id="20" name="Text 18"/>
+          <p:cNvPr id="21" name="Text 18"/>
           <p:cNvSpPr txBox="1"/>
           <p:nvPr/>
         </p:nvSpPr>
@@ -6829,7 +6885,7 @@
       </p:sp>
       <p:sp>
         <p:nvSpPr>
-          <p:cNvPr id="9" name="Shape 7"/>
+          <p:cNvPr id="10" name="Shape 7"/>
           <p:cNvSpPr/>
           <p:nvPr/>
         </p:nvSpPr>
@@ -6849,7 +6905,7 @@
       </p:sp>
       <p:sp>
         <p:nvSpPr>
-          <p:cNvPr id="10" name="Text 8"/>
+          <p:cNvPr id="11" name="Text 8"/>
           <p:cNvSpPr txBox="1"/>
           <p:nvPr/>
         </p:nvSpPr>
@@ -6872,7 +6928,7 @@
               <a:buNone/>
             </a:pPr>
             <a:r>
-              <a:rPr lang="en-US" sz="1500" b="1" dirty="0">
+              <a:rPr lang="en-US" sz="1600" b="1" dirty="0">
                 <a:solidFill>
                   <a:srgbClr val="2D2D2D"/>
                 </a:solidFill>
@@ -6882,13 +6938,13 @@
               </a:rPr>
               <a:t>重申核心论点</a:t>
             </a:r>
-            <a:endParaRPr lang="en-US" sz="1500" dirty="0"/>
-          </a:p>
-        </p:txBody>
-      </p:sp>
-      <p:sp>
-        <p:nvSpPr>
-          <p:cNvPr id="11" name="Text 9"/>
+            <a:endParaRPr lang="en-US" sz="1600" dirty="0"/>
+          </a:p>
+        </p:txBody>
+      </p:sp>
+      <p:sp>
+        <p:nvSpPr>
+          <p:cNvPr id="12" name="Text 9"/>
           <p:cNvSpPr txBox="1"/>
           <p:nvPr/>
         </p:nvSpPr>
@@ -6917,7 +6973,7 @@
               <a:buNone/>
             </a:pPr>
             <a:r>
-              <a:rPr lang="en-US" sz="1150" dirty="0">
+              <a:rPr lang="en-US" sz="1450" dirty="0">
                 <a:solidFill>
                   <a:srgbClr val="2D2D2D"/>
                 </a:solidFill>
@@ -6925,15 +6981,15 @@
                 <a:ea typeface="Microsoft YaHei" pitchFamily="34" charset="-122"/>
                 <a:cs typeface="Microsoft YaHei" pitchFamily="34" charset="-120"/>
               </a:rPr>
-              <a:t>在文章的结论部分，作者需要重申核心论点，确保读者清晰理解文章的成果。这有助于巩固读者对文章主要观点的记忆，使文章的结论更加深刻。</a:t>
-            </a:r>
-            <a:endParaRPr lang="en-US" sz="1150" dirty="0"/>
-          </a:p>
-        </p:txBody>
-      </p:sp>
-      <p:sp>
-        <p:nvSpPr>
-          <p:cNvPr id="12" name="Shape 10"/>
+              <a:t>在结论中重申核心论点，巩固读者对主要观点的记忆，让结论更深刻。</a:t>
+            </a:r>
+            <a:endParaRPr lang="en-US" sz="1450" dirty="0"/>
+          </a:p>
+        </p:txBody>
+      </p:sp>
+      <p:sp>
+        <p:nvSpPr>
+          <p:cNvPr id="13" name="Shape 10"/>
           <p:cNvSpPr/>
           <p:nvPr/>
         </p:nvSpPr>
@@ -6953,7 +7009,7 @@
       </p:sp>
       <p:sp>
         <p:nvSpPr>
-          <p:cNvPr id="13" name="Text 11"/>
+          <p:cNvPr id="14" name="Text 11"/>
           <p:cNvSpPr txBox="1"/>
           <p:nvPr/>
         </p:nvSpPr>
@@ -6976,7 +7032,7 @@
               <a:buNone/>
             </a:pPr>
             <a:r>
-              <a:rPr lang="en-US" sz="1500" b="1" dirty="0">
+              <a:rPr lang="en-US" sz="1600" b="1" dirty="0">
                 <a:solidFill>
                   <a:srgbClr val="2D2D2D"/>
                 </a:solidFill>
@@ -6986,13 +7042,13 @@
               </a:rPr>
               <a:t>简要总结研究的主要发现</a:t>
             </a:r>
-            <a:endParaRPr lang="en-US" sz="1500" dirty="0"/>
-          </a:p>
-        </p:txBody>
-      </p:sp>
-      <p:sp>
-        <p:nvSpPr>
-          <p:cNvPr id="14" name="Text 12"/>
+            <a:endParaRPr lang="en-US" sz="1600" dirty="0"/>
+          </a:p>
+        </p:txBody>
+      </p:sp>
+      <p:sp>
+        <p:nvSpPr>
+          <p:cNvPr id="15" name="Text 12"/>
           <p:cNvSpPr txBox="1"/>
           <p:nvPr/>
         </p:nvSpPr>
@@ -7021,7 +7077,7 @@
               <a:buNone/>
             </a:pPr>
             <a:r>
-              <a:rPr lang="en-US" sz="1150" dirty="0">
+              <a:rPr lang="en-US" sz="1450" dirty="0">
                 <a:solidFill>
                   <a:srgbClr val="2D2D2D"/>
                 </a:solidFill>
@@ -7029,15 +7085,15 @@
                 <a:ea typeface="Microsoft YaHei" pitchFamily="34" charset="-122"/>
                 <a:cs typeface="Microsoft YaHei" pitchFamily="34" charset="-120"/>
               </a:rPr>
-              <a:t>在结论部分，作者应该简要总结研究的主要发现。这应该包括研究的关键结果和结论，以及这些结果的意义。通过简洁明了的总结，读者可以快速把握文章的核心内容。</a:t>
-            </a:r>
-            <a:endParaRPr lang="en-US" sz="1150" dirty="0"/>
+              <a:t>简明概括关键结果、结论及其意义，帮助读者快速把握核心内容。</a:t>
+            </a:r>
+            <a:endParaRPr lang="en-US" sz="1450" dirty="0"/>
           </a:p>
         </p:txBody>
       </p:sp>
       <p:pic>
         <p:nvPicPr>
-          <p:cNvPr id="15" name="Image 0" descr="p11_2">    </p:cNvPr>
+          <p:cNvPr id="16" name="Image 0" descr="p11_2">    </p:cNvPr>
           <p:cNvPicPr>
             <a:picLocks noChangeAspect="1"/>
           </p:cNvPicPr>
@@ -7061,7 +7117,7 @@
       </p:pic>
       <p:pic>
         <p:nvPicPr>
-          <p:cNvPr id="16" name="Image 1" descr="p11_1">    </p:cNvPr>
+          <p:cNvPr id="17" name="Image 1" descr="p11_1">    </p:cNvPr>
           <p:cNvPicPr>
             <a:picLocks noChangeAspect="1"/>
           </p:cNvPicPr>
@@ -7085,7 +7141,7 @@
       </p:pic>
       <p:pic>
         <p:nvPicPr>
-          <p:cNvPr id="17" name="Image 2" descr="p11_4">    </p:cNvPr>
+          <p:cNvPr id="18" name="Image 2" descr="p11_4">    </p:cNvPr>
           <p:cNvPicPr>
             <a:picLocks noChangeAspect="1"/>
           </p:cNvPicPr>
@@ -8028,7 +8084,7 @@
       </p:sp>
       <p:sp>
         <p:nvSpPr>
-          <p:cNvPr id="9" name="Shape 7"/>
+          <p:cNvPr id="10" name="Shape 7"/>
           <p:cNvSpPr/>
           <p:nvPr/>
         </p:nvSpPr>
@@ -8048,7 +8104,7 @@
       </p:sp>
       <p:sp>
         <p:nvSpPr>
-          <p:cNvPr id="10" name="Text 8"/>
+          <p:cNvPr id="11" name="Text 8"/>
           <p:cNvSpPr txBox="1"/>
           <p:nvPr/>
         </p:nvSpPr>
@@ -8087,7 +8143,7 @@
       </p:sp>
       <p:sp>
         <p:nvSpPr>
-          <p:cNvPr id="11" name="Text 9"/>
+          <p:cNvPr id="12" name="Text 9"/>
           <p:cNvSpPr txBox="1"/>
           <p:nvPr/>
         </p:nvSpPr>
@@ -8126,7 +8182,7 @@
       </p:sp>
       <p:sp>
         <p:nvSpPr>
-          <p:cNvPr id="12" name="Shape 10"/>
+          <p:cNvPr id="13" name="Shape 10"/>
           <p:cNvSpPr/>
           <p:nvPr/>
         </p:nvSpPr>
@@ -8146,7 +8202,7 @@
       </p:sp>
       <p:sp>
         <p:nvSpPr>
-          <p:cNvPr id="13" name="Text 11"/>
+          <p:cNvPr id="14" name="Text 11"/>
           <p:cNvSpPr txBox="1"/>
           <p:nvPr/>
         </p:nvSpPr>
@@ -8169,7 +8225,7 @@
               <a:buNone/>
             </a:pPr>
             <a:r>
-              <a:rPr lang="en-US" sz="1500" b="1" dirty="0">
+              <a:rPr lang="en-US" sz="1600" b="1" dirty="0">
                 <a:solidFill>
                   <a:srgbClr val="2D2D2D"/>
                 </a:solidFill>
@@ -8179,13 +8235,13 @@
               </a:rPr>
               <a:t>精准传达文章主题</a:t>
             </a:r>
-            <a:endParaRPr lang="en-US" sz="1500" dirty="0"/>
-          </a:p>
-        </p:txBody>
-      </p:sp>
-      <p:sp>
-        <p:nvSpPr>
-          <p:cNvPr id="14" name="Text 12"/>
+            <a:endParaRPr lang="en-US" sz="1600" dirty="0"/>
+          </a:p>
+        </p:txBody>
+      </p:sp>
+      <p:sp>
+        <p:nvSpPr>
+          <p:cNvPr id="15" name="Text 12"/>
           <p:cNvSpPr txBox="1"/>
           <p:nvPr/>
         </p:nvSpPr>
@@ -8214,7 +8270,7 @@
               <a:buNone/>
             </a:pPr>
             <a:r>
-              <a:rPr lang="en-US" sz="1150" dirty="0">
+              <a:rPr lang="en-US" sz="1450" dirty="0">
                 <a:solidFill>
                   <a:srgbClr val="2D2D2D"/>
                 </a:solidFill>
@@ -8222,15 +8278,15 @@
                 <a:ea typeface="Microsoft YaHei" pitchFamily="34" charset="-122"/>
                 <a:cs typeface="Microsoft YaHei" pitchFamily="34" charset="-120"/>
               </a:rPr>
-              <a:t>一个好的标题应该能够精准传达文章的主题和研究对象。作者应该避免使用冗长或复杂的语言，而是要力求简洁明了。这样不仅能够吸引读者的注意力，还能够帮助读者快速理解文章的内容。</a:t>
-            </a:r>
-            <a:endParaRPr lang="en-US" sz="1150" dirty="0"/>
-          </a:p>
-        </p:txBody>
-      </p:sp>
-      <p:sp>
-        <p:nvSpPr>
-          <p:cNvPr id="15" name="Shape 13"/>
+              <a:t>好标题精准传达文章的主题和研究对象，既吸引注意力，又帮助读者快速理解内容。</a:t>
+            </a:r>
+            <a:endParaRPr lang="en-US" sz="1450" dirty="0"/>
+          </a:p>
+        </p:txBody>
+      </p:sp>
+      <p:sp>
+        <p:nvSpPr>
+          <p:cNvPr id="16" name="Shape 13"/>
           <p:cNvSpPr/>
           <p:nvPr/>
         </p:nvSpPr>
@@ -8250,7 +8306,7 @@
       </p:sp>
       <p:sp>
         <p:nvSpPr>
-          <p:cNvPr id="16" name="Text 14"/>
+          <p:cNvPr id="17" name="Text 14"/>
           <p:cNvSpPr txBox="1"/>
           <p:nvPr/>
         </p:nvSpPr>
@@ -8273,7 +8329,7 @@
               <a:buNone/>
             </a:pPr>
             <a:r>
-              <a:rPr lang="en-US" sz="1500" b="1" dirty="0">
+              <a:rPr lang="en-US" sz="1600" b="1" dirty="0">
                 <a:solidFill>
                   <a:srgbClr val="2D2D2D"/>
                 </a:solidFill>
@@ -8283,13 +8339,13 @@
               </a:rPr>
               <a:t>避免使用冗长语言</a:t>
             </a:r>
-            <a:endParaRPr lang="en-US" sz="1500" dirty="0"/>
-          </a:p>
-        </p:txBody>
-      </p:sp>
-      <p:sp>
-        <p:nvSpPr>
-          <p:cNvPr id="17" name="Text 15"/>
+            <a:endParaRPr lang="en-US" sz="1600" dirty="0"/>
+          </a:p>
+        </p:txBody>
+      </p:sp>
+      <p:sp>
+        <p:nvSpPr>
+          <p:cNvPr id="18" name="Text 15"/>
           <p:cNvSpPr txBox="1"/>
           <p:nvPr/>
         </p:nvSpPr>
@@ -8318,7 +8374,7 @@
               <a:buNone/>
             </a:pPr>
             <a:r>
-              <a:rPr lang="en-US" sz="1150" dirty="0">
+              <a:rPr lang="en-US" sz="1450" dirty="0">
                 <a:solidFill>
                   <a:srgbClr val="2D2D2D"/>
                 </a:solidFill>
@@ -8326,9 +8382,9 @@
                 <a:ea typeface="Microsoft YaHei" pitchFamily="34" charset="-122"/>
                 <a:cs typeface="Microsoft YaHei" pitchFamily="34" charset="-120"/>
               </a:rPr>
-              <a:t>在修改标题时，作者应该避免使用冗长或复杂的语言。冗长的标题可能会让读者感到困惑，甚至失去阅读的兴趣。因此，作者应该力求标题的简洁性，使其一目了然。</a:t>
-            </a:r>
-            <a:endParaRPr lang="en-US" sz="1150" dirty="0"/>
+              <a:t>冗长复杂的标题令人困惑，甚至失去阅读兴趣——力求简洁，一目了然。</a:t>
+            </a:r>
+            <a:endParaRPr lang="en-US" sz="1450" dirty="0"/>
           </a:p>
         </p:txBody>
       </p:sp>
@@ -8603,7 +8659,7 @@
       </p:sp>
       <p:sp>
         <p:nvSpPr>
-          <p:cNvPr id="9" name="Shape 7"/>
+          <p:cNvPr id="10" name="Shape 7"/>
           <p:cNvSpPr/>
           <p:nvPr/>
         </p:nvSpPr>
@@ -8623,7 +8679,7 @@
       </p:sp>
       <p:sp>
         <p:nvSpPr>
-          <p:cNvPr id="10" name="Text 8"/>
+          <p:cNvPr id="11" name="Text 8"/>
           <p:cNvSpPr txBox="1"/>
           <p:nvPr/>
         </p:nvSpPr>
@@ -8662,7 +8718,7 @@
       </p:sp>
       <p:sp>
         <p:nvSpPr>
-          <p:cNvPr id="11" name="Text 9"/>
+          <p:cNvPr id="12" name="Text 9"/>
           <p:cNvSpPr txBox="1"/>
           <p:nvPr/>
         </p:nvSpPr>
@@ -8701,7 +8757,7 @@
       </p:sp>
       <p:sp>
         <p:nvSpPr>
-          <p:cNvPr id="12" name="Shape 10"/>
+          <p:cNvPr id="13" name="Shape 10"/>
           <p:cNvSpPr/>
           <p:nvPr/>
         </p:nvSpPr>
@@ -8721,7 +8777,7 @@
       </p:sp>
       <p:sp>
         <p:nvSpPr>
-          <p:cNvPr id="13" name="Text 11"/>
+          <p:cNvPr id="14" name="Text 11"/>
           <p:cNvSpPr txBox="1"/>
           <p:nvPr/>
         </p:nvSpPr>
@@ -8760,7 +8816,7 @@
       </p:sp>
       <p:sp>
         <p:nvSpPr>
-          <p:cNvPr id="14" name="Text 12"/>
+          <p:cNvPr id="15" name="Text 12"/>
           <p:cNvSpPr txBox="1"/>
           <p:nvPr/>
         </p:nvSpPr>
@@ -8781,12 +8837,12 @@
           <a:p>
             <a:pPr indent="0" marL="0">
               <a:lnSpc>
-                <a:spcPct val="140000"/>
+                <a:spcPct val="145000"/>
               </a:lnSpc>
               <a:buNone/>
             </a:pPr>
             <a:r>
-              <a:rPr lang="en-US" sz="1150" dirty="0">
+              <a:rPr lang="en-US" sz="1500" dirty="0">
                 <a:solidFill>
                   <a:srgbClr val="2D2D2D"/>
                 </a:solidFill>
@@ -8794,15 +8850,15 @@
                 <a:ea typeface="Microsoft YaHei" pitchFamily="34" charset="-122"/>
                 <a:cs typeface="Microsoft YaHei" pitchFamily="34" charset="-120"/>
               </a:rPr>
-              <a:t>标题应该包含研究的核心内容或关键词，使读者一目了然地了解文章的研究方向。这有助于提高文章的可读性，让读者在阅读全文之前就对文章的主题有一个大致的了解。</a:t>
-            </a:r>
-            <a:endParaRPr lang="en-US" sz="1150" dirty="0"/>
-          </a:p>
-        </p:txBody>
-      </p:sp>
-      <p:sp>
-        <p:nvSpPr>
-          <p:cNvPr id="15" name="Shape 13"/>
+              <a:t>包含研究的核心内容或关键词，让读者在读全文之前就了解研究方向。</a:t>
+            </a:r>
+            <a:endParaRPr lang="en-US" sz="1500" dirty="0"/>
+          </a:p>
+        </p:txBody>
+      </p:sp>
+      <p:sp>
+        <p:nvSpPr>
+          <p:cNvPr id="16" name="Shape 13"/>
           <p:cNvSpPr/>
           <p:nvPr/>
         </p:nvSpPr>
@@ -8822,7 +8878,7 @@
       </p:sp>
       <p:sp>
         <p:nvSpPr>
-          <p:cNvPr id="16" name="Text 14"/>
+          <p:cNvPr id="17" name="Text 14"/>
           <p:cNvSpPr txBox="1"/>
           <p:nvPr/>
         </p:nvSpPr>
@@ -8861,7 +8917,7 @@
       </p:sp>
       <p:sp>
         <p:nvSpPr>
-          <p:cNvPr id="17" name="Text 15"/>
+          <p:cNvPr id="18" name="Text 15"/>
           <p:cNvSpPr txBox="1"/>
           <p:nvPr/>
         </p:nvSpPr>
@@ -8900,7 +8956,7 @@
       </p:sp>
       <p:sp>
         <p:nvSpPr>
-          <p:cNvPr id="18" name="Shape 16"/>
+          <p:cNvPr id="19" name="Shape 16"/>
           <p:cNvSpPr/>
           <p:nvPr/>
         </p:nvSpPr>
@@ -8920,7 +8976,7 @@
       </p:sp>
       <p:sp>
         <p:nvSpPr>
-          <p:cNvPr id="19" name="Text 17"/>
+          <p:cNvPr id="20" name="Text 17"/>
           <p:cNvSpPr txBox="1"/>
           <p:nvPr/>
         </p:nvSpPr>
@@ -8959,7 +9015,7 @@
       </p:sp>
       <p:sp>
         <p:nvSpPr>
-          <p:cNvPr id="20" name="Text 18"/>
+          <p:cNvPr id="21" name="Text 18"/>
           <p:cNvSpPr txBox="1"/>
           <p:nvPr/>
         </p:nvSpPr>
@@ -8980,12 +9036,12 @@
           <a:p>
             <a:pPr indent="0" marL="0">
               <a:lnSpc>
-                <a:spcPct val="140000"/>
+                <a:spcPct val="145000"/>
               </a:lnSpc>
               <a:buNone/>
             </a:pPr>
             <a:r>
-              <a:rPr lang="en-US" sz="1150" dirty="0">
+              <a:rPr lang="en-US" sz="1500" dirty="0">
                 <a:solidFill>
                   <a:srgbClr val="2D2D2D"/>
                 </a:solidFill>
@@ -8993,9 +9049,9 @@
                 <a:ea typeface="Microsoft YaHei" pitchFamily="34" charset="-122"/>
                 <a:cs typeface="Microsoft YaHei" pitchFamily="34" charset="-120"/>
               </a:rPr>
-              <a:t>在修改标题时，作者应该确保标题能够概括文章的重点，包括研究对象、方法或发现。这样不仅能够吸引读者的注意力，还能够帮助读者快速定位文章的核心内容。</a:t>
-            </a:r>
-            <a:endParaRPr lang="en-US" sz="1150" dirty="0"/>
+              <a:t>概括研究对象、方法或发现，帮助读者快速定位文章的核心内容。</a:t>
+            </a:r>
+            <a:endParaRPr lang="en-US" sz="1500" dirty="0"/>
           </a:p>
         </p:txBody>
       </p:sp>
@@ -9270,7 +9326,7 @@
       </p:sp>
       <p:sp>
         <p:nvSpPr>
-          <p:cNvPr id="9" name="Text 7"/>
+          <p:cNvPr id="10" name="Text 7"/>
           <p:cNvSpPr txBox="1"/>
           <p:nvPr/>
         </p:nvSpPr>
@@ -9309,7 +9365,7 @@
       </p:sp>
       <p:sp>
         <p:nvSpPr>
-          <p:cNvPr id="10" name="Shape 8"/>
+          <p:cNvPr id="11" name="Shape 8"/>
           <p:cNvSpPr/>
           <p:nvPr/>
         </p:nvSpPr>
@@ -9329,7 +9385,7 @@
       </p:sp>
       <p:sp>
         <p:nvSpPr>
-          <p:cNvPr id="11" name="Shape 9"/>
+          <p:cNvPr id="12" name="Shape 9"/>
           <p:cNvSpPr/>
           <p:nvPr/>
         </p:nvSpPr>
@@ -9349,7 +9405,7 @@
       </p:sp>
       <p:sp>
         <p:nvSpPr>
-          <p:cNvPr id="12" name="Text 10"/>
+          <p:cNvPr id="13" name="Text 10"/>
           <p:cNvSpPr txBox="1"/>
           <p:nvPr/>
         </p:nvSpPr>
@@ -9388,7 +9444,7 @@
       </p:sp>
       <p:sp>
         <p:nvSpPr>
-          <p:cNvPr id="13" name="Text 11"/>
+          <p:cNvPr id="14" name="Text 11"/>
           <p:cNvSpPr txBox="1"/>
           <p:nvPr/>
         </p:nvSpPr>
@@ -9411,7 +9467,7 @@
               <a:buNone/>
             </a:pPr>
             <a:r>
-              <a:rPr lang="en-US" sz="1500" b="1" dirty="0">
+              <a:rPr lang="en-US" sz="1700" b="1" dirty="0">
                 <a:solidFill>
                   <a:srgbClr val="2D2D2D"/>
                 </a:solidFill>
@@ -9421,13 +9477,13 @@
               </a:rPr>
               <a:t>在标题中加入创新性词语</a:t>
             </a:r>
-            <a:endParaRPr lang="en-US" sz="1500" dirty="0"/>
-          </a:p>
-        </p:txBody>
-      </p:sp>
-      <p:sp>
-        <p:nvSpPr>
-          <p:cNvPr id="14" name="Text 12"/>
+            <a:endParaRPr lang="en-US" sz="1700" dirty="0"/>
+          </a:p>
+        </p:txBody>
+      </p:sp>
+      <p:sp>
+        <p:nvSpPr>
+          <p:cNvPr id="15" name="Text 12"/>
           <p:cNvSpPr txBox="1"/>
           <p:nvPr/>
         </p:nvSpPr>
@@ -9456,7 +9512,7 @@
               <a:buNone/>
             </a:pPr>
             <a:r>
-              <a:rPr lang="en-US" sz="1150" dirty="0">
+              <a:rPr lang="en-US" sz="1500" dirty="0">
                 <a:solidFill>
                   <a:srgbClr val="2D2D2D"/>
                 </a:solidFill>
@@ -9464,15 +9520,15 @@
                 <a:ea typeface="Microsoft YaHei" pitchFamily="34" charset="-122"/>
                 <a:cs typeface="Microsoft YaHei" pitchFamily="34" charset="-120"/>
               </a:rPr>
-              <a:t>为了增加标题的创新性，作者可以在标题中加入能够展示创新性的词语。例如，如果研究涉及新方法或新理论，可以在标题中加以强调。这样的标题能够吸引读者的兴趣，使他们更愿意阅读全文。</a:t>
-            </a:r>
-            <a:endParaRPr lang="en-US" sz="1150" dirty="0"/>
-          </a:p>
-        </p:txBody>
-      </p:sp>
-      <p:sp>
-        <p:nvSpPr>
-          <p:cNvPr id="15" name="Shape 13"/>
+              <a:t>研究涉及新方法或新理论时，在标题中加以强调，让读者更愿意阅读全文。</a:t>
+            </a:r>
+            <a:endParaRPr lang="en-US" sz="1500" dirty="0"/>
+          </a:p>
+        </p:txBody>
+      </p:sp>
+      <p:sp>
+        <p:nvSpPr>
+          <p:cNvPr id="16" name="Shape 13"/>
           <p:cNvSpPr/>
           <p:nvPr/>
         </p:nvSpPr>
@@ -9492,7 +9548,7 @@
       </p:sp>
       <p:sp>
         <p:nvSpPr>
-          <p:cNvPr id="16" name="Text 14"/>
+          <p:cNvPr id="17" name="Text 14"/>
           <p:cNvSpPr txBox="1"/>
           <p:nvPr/>
         </p:nvSpPr>
@@ -9531,7 +9587,7 @@
       </p:sp>
       <p:sp>
         <p:nvSpPr>
-          <p:cNvPr id="17" name="Text 15"/>
+          <p:cNvPr id="18" name="Text 15"/>
           <p:cNvSpPr txBox="1"/>
           <p:nvPr/>
         </p:nvSpPr>
@@ -9554,7 +9610,7 @@
               <a:buNone/>
             </a:pPr>
             <a:r>
-              <a:rPr lang="en-US" sz="1500" b="1" dirty="0">
+              <a:rPr lang="en-US" sz="1700" b="1" dirty="0">
                 <a:solidFill>
                   <a:srgbClr val="2D2D2D"/>
                 </a:solidFill>
@@ -9564,13 +9620,13 @@
               </a:rPr>
               <a:t>吸引读者兴趣</a:t>
             </a:r>
-            <a:endParaRPr lang="en-US" sz="1500" dirty="0"/>
-          </a:p>
-        </p:txBody>
-      </p:sp>
-      <p:sp>
-        <p:nvSpPr>
-          <p:cNvPr id="18" name="Text 16"/>
+            <a:endParaRPr lang="en-US" sz="1700" dirty="0"/>
+          </a:p>
+        </p:txBody>
+      </p:sp>
+      <p:sp>
+        <p:nvSpPr>
+          <p:cNvPr id="19" name="Text 16"/>
           <p:cNvSpPr txBox="1"/>
           <p:nvPr/>
         </p:nvSpPr>
@@ -9599,7 +9655,7 @@
               <a:buNone/>
             </a:pPr>
             <a:r>
-              <a:rPr lang="en-US" sz="1150" dirty="0">
+              <a:rPr lang="en-US" sz="1500" dirty="0">
                 <a:solidFill>
                   <a:srgbClr val="2D2D2D"/>
                 </a:solidFill>
@@ -9607,9 +9663,9 @@
                 <a:ea typeface="Microsoft YaHei" pitchFamily="34" charset="-122"/>
                 <a:cs typeface="Microsoft YaHei" pitchFamily="34" charset="-120"/>
               </a:rPr>
-              <a:t>在修改标题时，作者应该考虑如何吸引读者的兴趣。一个具有创新性的标题能够激发读者的好奇心，促使他们进一步探索文章的内容。</a:t>
-            </a:r>
-            <a:endParaRPr lang="en-US" sz="1150" dirty="0"/>
+              <a:t>修改标题时思考如何吸引读者，促使他们进一步探索文章内容。</a:t>
+            </a:r>
+            <a:endParaRPr lang="en-US" sz="1500" dirty="0"/>
           </a:p>
         </p:txBody>
       </p:sp>
@@ -9884,7 +9940,7 @@
       </p:sp>
       <p:sp>
         <p:nvSpPr>
-          <p:cNvPr id="9" name="Shape 7"/>
+          <p:cNvPr id="10" name="Shape 7"/>
           <p:cNvSpPr/>
           <p:nvPr/>
         </p:nvSpPr>
@@ -9904,7 +9960,7 @@
       </p:sp>
       <p:sp>
         <p:nvSpPr>
-          <p:cNvPr id="10" name="Text 8"/>
+          <p:cNvPr id="11" name="Text 8"/>
           <p:cNvSpPr txBox="1"/>
           <p:nvPr/>
         </p:nvSpPr>
@@ -9943,7 +9999,7 @@
       </p:sp>
       <p:sp>
         <p:nvSpPr>
-          <p:cNvPr id="11" name="Text 9"/>
+          <p:cNvPr id="12" name="Text 9"/>
           <p:cNvSpPr txBox="1"/>
           <p:nvPr/>
         </p:nvSpPr>
@@ -9982,7 +10038,7 @@
       </p:sp>
       <p:sp>
         <p:nvSpPr>
-          <p:cNvPr id="12" name="Text 10"/>
+          <p:cNvPr id="13" name="Text 10"/>
           <p:cNvSpPr txBox="1"/>
           <p:nvPr/>
         </p:nvSpPr>
@@ -10008,7 +10064,7 @@
               <a:buNone/>
             </a:pPr>
             <a:r>
-              <a:rPr lang="en-US" sz="1150" dirty="0">
+              <a:rPr lang="en-US" sz="1450" dirty="0">
                 <a:solidFill>
                   <a:srgbClr val="2D2D2D"/>
                 </a:solidFill>
@@ -10016,15 +10072,15 @@
                 <a:ea typeface="Microsoft YaHei" pitchFamily="34" charset="-122"/>
                 <a:cs typeface="Microsoft YaHei" pitchFamily="34" charset="-120"/>
               </a:rPr>
-              <a:t>在修改标题时，作者应该考虑读者的检索需求。标题应包含易于检索的关键词，使文章在学术数据库中更易被找到。这样不仅能够提高文章的引用率，还能够增加读者的阅读和引用可能性。</a:t>
-            </a:r>
-            <a:endParaRPr lang="en-US" sz="1150" dirty="0"/>
-          </a:p>
-        </p:txBody>
-      </p:sp>
-      <p:sp>
-        <p:nvSpPr>
-          <p:cNvPr id="13" name="Shape 11"/>
+              <a:t>让文章在学术数据库中更易被找到，提高阅读与引用的可能性。</a:t>
+            </a:r>
+            <a:endParaRPr lang="en-US" sz="1450" dirty="0"/>
+          </a:p>
+        </p:txBody>
+      </p:sp>
+      <p:sp>
+        <p:nvSpPr>
+          <p:cNvPr id="14" name="Shape 11"/>
           <p:cNvSpPr/>
           <p:nvPr/>
         </p:nvSpPr>
@@ -10044,7 +10100,7 @@
       </p:sp>
       <p:sp>
         <p:nvSpPr>
-          <p:cNvPr id="14" name="Text 12"/>
+          <p:cNvPr id="15" name="Text 12"/>
           <p:cNvSpPr txBox="1"/>
           <p:nvPr/>
         </p:nvSpPr>
@@ -10083,7 +10139,7 @@
       </p:sp>
       <p:sp>
         <p:nvSpPr>
-          <p:cNvPr id="15" name="Text 13"/>
+          <p:cNvPr id="16" name="Text 13"/>
           <p:cNvSpPr txBox="1"/>
           <p:nvPr/>
         </p:nvSpPr>
@@ -10122,7 +10178,7 @@
       </p:sp>
       <p:sp>
         <p:nvSpPr>
-          <p:cNvPr id="16" name="Text 14"/>
+          <p:cNvPr id="17" name="Text 14"/>
           <p:cNvSpPr txBox="1"/>
           <p:nvPr/>
         </p:nvSpPr>
@@ -10148,7 +10204,7 @@
               <a:buNone/>
             </a:pPr>
             <a:r>
-              <a:rPr lang="en-US" sz="1150" dirty="0">
+              <a:rPr lang="en-US" sz="1450" dirty="0">
                 <a:solidFill>
                   <a:srgbClr val="2D2D2D"/>
                 </a:solidFill>
@@ -10156,15 +10212,15 @@
                 <a:ea typeface="Microsoft YaHei" pitchFamily="34" charset="-122"/>
                 <a:cs typeface="Microsoft YaHei" pitchFamily="34" charset="-120"/>
               </a:rPr>
-              <a:t>为了提高文章的可发现性，作者应该在标题中包含易于检索的关键词。这些关键词应该与研究的主题和内容紧密相关，以便读者在搜索时能够快速找到相关文章。</a:t>
-            </a:r>
-            <a:endParaRPr lang="en-US" sz="1150" dirty="0"/>
-          </a:p>
-        </p:txBody>
-      </p:sp>
-      <p:sp>
-        <p:nvSpPr>
-          <p:cNvPr id="17" name="Shape 15"/>
+              <a:t>关键词应与研究主题和内容紧密相关，便于读者搜索时快速找到。</a:t>
+            </a:r>
+            <a:endParaRPr lang="en-US" sz="1450" dirty="0"/>
+          </a:p>
+        </p:txBody>
+      </p:sp>
+      <p:sp>
+        <p:nvSpPr>
+          <p:cNvPr id="18" name="Shape 15"/>
           <p:cNvSpPr/>
           <p:nvPr/>
         </p:nvSpPr>
@@ -10189,7 +10245,7 @@
       </p:sp>
       <p:sp>
         <p:nvSpPr>
-          <p:cNvPr id="18" name="Text 16"/>
+          <p:cNvPr id="19" name="Text 16"/>
           <p:cNvSpPr txBox="1"/>
           <p:nvPr/>
         </p:nvSpPr>
@@ -14753,7 +14809,7 @@
       </p:sp>
       <p:sp>
         <p:nvSpPr>
-          <p:cNvPr id="9" name="Shape 7"/>
+          <p:cNvPr id="10" name="Shape 7"/>
           <p:cNvSpPr/>
           <p:nvPr/>
         </p:nvSpPr>
@@ -14773,7 +14829,7 @@
       </p:sp>
       <p:sp>
         <p:nvSpPr>
-          <p:cNvPr id="10" name="Text 8"/>
+          <p:cNvPr id="11" name="Text 8"/>
           <p:cNvSpPr txBox="1"/>
           <p:nvPr/>
         </p:nvSpPr>
@@ -14812,7 +14868,7 @@
       </p:sp>
       <p:sp>
         <p:nvSpPr>
-          <p:cNvPr id="11" name="Text 9"/>
+          <p:cNvPr id="12" name="Text 9"/>
           <p:cNvSpPr txBox="1"/>
           <p:nvPr/>
         </p:nvSpPr>
@@ -14835,7 +14891,7 @@
               <a:buNone/>
             </a:pPr>
             <a:r>
-              <a:rPr lang="en-US" sz="1400" b="1" dirty="0">
+              <a:rPr lang="en-US" sz="1450" b="1" dirty="0">
                 <a:solidFill>
                   <a:srgbClr val="2D2D2D"/>
                 </a:solidFill>
@@ -14845,13 +14901,13 @@
               </a:rPr>
               <a:t>研究背景的组成部分</a:t>
             </a:r>
-            <a:endParaRPr lang="en-US" sz="1400" dirty="0"/>
-          </a:p>
-        </p:txBody>
-      </p:sp>
-      <p:sp>
-        <p:nvSpPr>
-          <p:cNvPr id="12" name="Text 10"/>
+            <a:endParaRPr lang="en-US" sz="1450" dirty="0"/>
+          </a:p>
+        </p:txBody>
+      </p:sp>
+      <p:sp>
+        <p:nvSpPr>
+          <p:cNvPr id="13" name="Text 10"/>
           <p:cNvSpPr txBox="1"/>
           <p:nvPr/>
         </p:nvSpPr>
@@ -14880,7 +14936,7 @@
               <a:buNone/>
             </a:pPr>
             <a:r>
-              <a:rPr lang="en-US" sz="1150" dirty="0">
+              <a:rPr lang="en-US" sz="1400" dirty="0">
                 <a:solidFill>
                   <a:srgbClr val="2D2D2D"/>
                 </a:solidFill>
@@ -14888,15 +14944,15 @@
                 <a:ea typeface="Microsoft YaHei" pitchFamily="34" charset="-122"/>
                 <a:cs typeface="Microsoft YaHei" pitchFamily="34" charset="-120"/>
               </a:rPr>
-              <a:t>研究背景主要包括问题的提出、国内外研究现状、研究意义和目的等几个部分，它们共同构成了研究背景的框架。</a:t>
-            </a:r>
-            <a:endParaRPr lang="en-US" sz="1150" dirty="0"/>
-          </a:p>
-        </p:txBody>
-      </p:sp>
-      <p:sp>
-        <p:nvSpPr>
-          <p:cNvPr id="13" name="Shape 11"/>
+              <a:t>问题的提出、国内外研究现状、研究意义和目的，共同构成研究背景的框架。</a:t>
+            </a:r>
+            <a:endParaRPr lang="en-US" sz="1400" dirty="0"/>
+          </a:p>
+        </p:txBody>
+      </p:sp>
+      <p:sp>
+        <p:nvSpPr>
+          <p:cNvPr id="14" name="Shape 11"/>
           <p:cNvSpPr/>
           <p:nvPr/>
         </p:nvSpPr>
@@ -14916,7 +14972,7 @@
       </p:sp>
       <p:sp>
         <p:nvSpPr>
-          <p:cNvPr id="14" name="Text 12"/>
+          <p:cNvPr id="15" name="Text 12"/>
           <p:cNvSpPr txBox="1"/>
           <p:nvPr/>
         </p:nvSpPr>
@@ -14955,7 +15011,7 @@
       </p:sp>
       <p:sp>
         <p:nvSpPr>
-          <p:cNvPr id="15" name="Text 13"/>
+          <p:cNvPr id="16" name="Text 13"/>
           <p:cNvSpPr txBox="1"/>
           <p:nvPr/>
         </p:nvSpPr>
@@ -14978,7 +15034,7 @@
               <a:buNone/>
             </a:pPr>
             <a:r>
-              <a:rPr lang="en-US" sz="1400" b="1" dirty="0">
+              <a:rPr lang="en-US" sz="1450" b="1" dirty="0">
                 <a:solidFill>
                   <a:srgbClr val="2D2D2D"/>
                 </a:solidFill>
@@ -14988,13 +15044,13 @@
               </a:rPr>
               <a:t>背景信息与研究的关联</a:t>
             </a:r>
-            <a:endParaRPr lang="en-US" sz="1400" dirty="0"/>
-          </a:p>
-        </p:txBody>
-      </p:sp>
-      <p:sp>
-        <p:nvSpPr>
-          <p:cNvPr id="16" name="Text 14"/>
+            <a:endParaRPr lang="en-US" sz="1450" dirty="0"/>
+          </a:p>
+        </p:txBody>
+      </p:sp>
+      <p:sp>
+        <p:nvSpPr>
+          <p:cNvPr id="17" name="Text 14"/>
           <p:cNvSpPr txBox="1"/>
           <p:nvPr/>
         </p:nvSpPr>
@@ -15023,7 +15079,7 @@
               <a:buNone/>
             </a:pPr>
             <a:r>
-              <a:rPr lang="en-US" sz="1150" dirty="0">
+              <a:rPr lang="en-US" sz="1400" dirty="0">
                 <a:solidFill>
                   <a:srgbClr val="2D2D2D"/>
                 </a:solidFill>
@@ -15031,15 +15087,15 @@
                 <a:ea typeface="Microsoft YaHei" pitchFamily="34" charset="-122"/>
                 <a:cs typeface="Microsoft YaHei" pitchFamily="34" charset="-120"/>
               </a:rPr>
-              <a:t>背景信息与研究主题紧密相连，为研究的展开提供了必要的背景支持和理论依据。</a:t>
-            </a:r>
-            <a:endParaRPr lang="en-US" sz="1150" dirty="0"/>
-          </a:p>
-        </p:txBody>
-      </p:sp>
-      <p:sp>
-        <p:nvSpPr>
-          <p:cNvPr id="17" name="Shape 15"/>
+              <a:t>背景信息与研究主题紧密相连，为研究提供背景支持与理论依据。</a:t>
+            </a:r>
+            <a:endParaRPr lang="en-US" sz="1400" dirty="0"/>
+          </a:p>
+        </p:txBody>
+      </p:sp>
+      <p:sp>
+        <p:nvSpPr>
+          <p:cNvPr id="18" name="Shape 15"/>
           <p:cNvSpPr/>
           <p:nvPr/>
         </p:nvSpPr>
@@ -15059,7 +15115,7 @@
       </p:sp>
       <p:sp>
         <p:nvSpPr>
-          <p:cNvPr id="18" name="Text 16"/>
+          <p:cNvPr id="19" name="Text 16"/>
           <p:cNvSpPr txBox="1"/>
           <p:nvPr/>
         </p:nvSpPr>
@@ -15098,7 +15154,7 @@
       </p:sp>
       <p:sp>
         <p:nvSpPr>
-          <p:cNvPr id="19" name="Text 17"/>
+          <p:cNvPr id="20" name="Text 17"/>
           <p:cNvSpPr txBox="1"/>
           <p:nvPr/>
         </p:nvSpPr>
@@ -15121,7 +15177,7 @@
               <a:buNone/>
             </a:pPr>
             <a:r>
-              <a:rPr lang="en-US" sz="1400" b="1" dirty="0">
+              <a:rPr lang="en-US" sz="1450" b="1" dirty="0">
                 <a:solidFill>
                   <a:srgbClr val="2D2D2D"/>
                 </a:solidFill>
@@ -15131,13 +15187,13 @@
               </a:rPr>
               <a:t>研究背景的逻辑框架</a:t>
             </a:r>
-            <a:endParaRPr lang="en-US" sz="1400" dirty="0"/>
-          </a:p>
-        </p:txBody>
-      </p:sp>
-      <p:sp>
-        <p:nvSpPr>
-          <p:cNvPr id="20" name="Text 18"/>
+            <a:endParaRPr lang="en-US" sz="1450" dirty="0"/>
+          </a:p>
+        </p:txBody>
+      </p:sp>
+      <p:sp>
+        <p:nvSpPr>
+          <p:cNvPr id="21" name="Text 18"/>
           <p:cNvSpPr txBox="1"/>
           <p:nvPr/>
         </p:nvSpPr>
@@ -15166,7 +15222,7 @@
               <a:buNone/>
             </a:pPr>
             <a:r>
-              <a:rPr lang="en-US" sz="1150" dirty="0">
+              <a:rPr lang="en-US" sz="1400" dirty="0">
                 <a:solidFill>
                   <a:srgbClr val="2D2D2D"/>
                 </a:solidFill>
@@ -15174,15 +15230,15 @@
                 <a:ea typeface="Microsoft YaHei" pitchFamily="34" charset="-122"/>
                 <a:cs typeface="Microsoft YaHei" pitchFamily="34" charset="-120"/>
               </a:rPr>
-              <a:t>研究背景的逻辑框架应清晰明确，从问题的提出到研究目的的设定，形成一个严密的结构体系。</a:t>
-            </a:r>
-            <a:endParaRPr lang="en-US" sz="1150" dirty="0"/>
-          </a:p>
-        </p:txBody>
-      </p:sp>
-      <p:sp>
-        <p:nvSpPr>
-          <p:cNvPr id="21" name="Shape 19"/>
+              <a:t>从问题的提出到研究目的的设定，形成清晰严密的结构体系。</a:t>
+            </a:r>
+            <a:endParaRPr lang="en-US" sz="1400" dirty="0"/>
+          </a:p>
+        </p:txBody>
+      </p:sp>
+      <p:sp>
+        <p:nvSpPr>
+          <p:cNvPr id="22" name="Shape 19"/>
           <p:cNvSpPr/>
           <p:nvPr/>
         </p:nvSpPr>
@@ -15202,7 +15258,7 @@
       </p:sp>
       <p:sp>
         <p:nvSpPr>
-          <p:cNvPr id="22" name="Text 20"/>
+          <p:cNvPr id="23" name="Text 20"/>
           <p:cNvSpPr txBox="1"/>
           <p:nvPr/>
         </p:nvSpPr>
@@ -15241,7 +15297,7 @@
       </p:sp>
       <p:sp>
         <p:nvSpPr>
-          <p:cNvPr id="23" name="Text 21"/>
+          <p:cNvPr id="24" name="Text 21"/>
           <p:cNvSpPr txBox="1"/>
           <p:nvPr/>
         </p:nvSpPr>
@@ -15264,7 +15320,7 @@
               <a:buNone/>
             </a:pPr>
             <a:r>
-              <a:rPr lang="en-US" sz="1400" b="1" dirty="0">
+              <a:rPr lang="en-US" sz="1450" b="1" dirty="0">
                 <a:solidFill>
                   <a:srgbClr val="FFFFFF"/>
                 </a:solidFill>
@@ -15274,13 +15330,13 @@
               </a:rPr>
               <a:t>研究背景的写作风格</a:t>
             </a:r>
-            <a:endParaRPr lang="en-US" sz="1400" dirty="0"/>
-          </a:p>
-        </p:txBody>
-      </p:sp>
-      <p:sp>
-        <p:nvSpPr>
-          <p:cNvPr id="24" name="Text 22"/>
+            <a:endParaRPr lang="en-US" sz="1450" dirty="0"/>
+          </a:p>
+        </p:txBody>
+      </p:sp>
+      <p:sp>
+        <p:nvSpPr>
+          <p:cNvPr id="25" name="Text 22"/>
           <p:cNvSpPr txBox="1"/>
           <p:nvPr/>
         </p:nvSpPr>
@@ -15309,7 +15365,7 @@
               <a:buNone/>
             </a:pPr>
             <a:r>
-              <a:rPr lang="en-US" sz="1150" dirty="0">
+              <a:rPr lang="en-US" sz="1400" dirty="0">
                 <a:solidFill>
                   <a:srgbClr val="FFFFFF"/>
                 </a:solidFill>
@@ -15317,9 +15373,9 @@
                 <a:ea typeface="Microsoft YaHei" pitchFamily="34" charset="-122"/>
                 <a:cs typeface="Microsoft YaHei" pitchFamily="34" charset="-120"/>
               </a:rPr>
-              <a:t>研究背景的写作应注重逻辑性、条理性和准确性，避免冗余和泛泛而谈，以确保读者能够快速理解研究背景。</a:t>
-            </a:r>
-            <a:endParaRPr lang="en-US" sz="1150" dirty="0"/>
+              <a:t>注重逻辑性、条理性和准确性，避免冗余和泛泛而谈。</a:t>
+            </a:r>
+            <a:endParaRPr lang="en-US" sz="1400" dirty="0"/>
           </a:p>
         </p:txBody>
       </p:sp>
@@ -15594,7 +15650,7 @@
       </p:sp>
       <p:sp>
         <p:nvSpPr>
-          <p:cNvPr id="9" name="Shape 7"/>
+          <p:cNvPr id="10" name="Shape 7"/>
           <p:cNvSpPr/>
           <p:nvPr/>
         </p:nvSpPr>
@@ -15614,7 +15670,7 @@
       </p:sp>
       <p:sp>
         <p:nvSpPr>
-          <p:cNvPr id="10" name="Text 8"/>
+          <p:cNvPr id="11" name="Text 8"/>
           <p:cNvSpPr txBox="1"/>
           <p:nvPr/>
         </p:nvSpPr>
@@ -15667,7 +15723,7 @@
       </p:sp>
       <p:sp>
         <p:nvSpPr>
-          <p:cNvPr id="11" name="Text 9"/>
+          <p:cNvPr id="12" name="Text 9"/>
           <p:cNvSpPr txBox="1"/>
           <p:nvPr/>
         </p:nvSpPr>
@@ -15693,7 +15749,7 @@
               <a:buNone/>
             </a:pPr>
             <a:r>
-              <a:rPr lang="en-US" sz="950" dirty="0">
+              <a:rPr lang="en-US" sz="1250" dirty="0">
                 <a:solidFill>
                   <a:srgbClr val="2D2D2D"/>
                 </a:solidFill>
@@ -15701,15 +15757,15 @@
                 <a:ea typeface="Microsoft YaHei" pitchFamily="34" charset="-122"/>
                 <a:cs typeface="Microsoft YaHei" pitchFamily="34" charset="-120"/>
               </a:rPr>
-              <a:t>国内外在该领域的研究已经取得了一系列进展，例如，国外研究者在理论模型构建方面有深入探索，而国内研究者则在实证分析方面取得了丰富成果。这些研究为我们提供了宝贵的基础资料，但也存在一定的局限性，需要进一步整合和创新。</a:t>
-            </a:r>
-            <a:endParaRPr lang="en-US" sz="950" dirty="0"/>
-          </a:p>
-        </p:txBody>
-      </p:sp>
-      <p:sp>
-        <p:nvSpPr>
-          <p:cNvPr id="12" name="Shape 10"/>
+              <a:t>国外侧重理论模型构建，国内在实证分析方面成果丰富；提供了宝贵基础，但仍需进一步整合与创新。</a:t>
+            </a:r>
+            <a:endParaRPr lang="en-US" sz="1250" dirty="0"/>
+          </a:p>
+        </p:txBody>
+      </p:sp>
+      <p:sp>
+        <p:nvSpPr>
+          <p:cNvPr id="13" name="Shape 10"/>
           <p:cNvSpPr/>
           <p:nvPr/>
         </p:nvSpPr>
@@ -15729,7 +15785,7 @@
       </p:sp>
       <p:sp>
         <p:nvSpPr>
-          <p:cNvPr id="13" name="Text 11"/>
+          <p:cNvPr id="14" name="Text 11"/>
           <p:cNvSpPr txBox="1"/>
           <p:nvPr/>
         </p:nvSpPr>
@@ -15782,7 +15838,7 @@
       </p:sp>
       <p:sp>
         <p:nvSpPr>
-          <p:cNvPr id="14" name="Text 12"/>
+          <p:cNvPr id="15" name="Text 12"/>
           <p:cNvSpPr txBox="1"/>
           <p:nvPr/>
         </p:nvSpPr>
@@ -15808,7 +15864,7 @@
               <a:buNone/>
             </a:pPr>
             <a:r>
-              <a:rPr lang="en-US" sz="950" dirty="0">
+              <a:rPr lang="en-US" sz="1250" dirty="0">
                 <a:solidFill>
                   <a:srgbClr val="2D2D2D"/>
                 </a:solidFill>
@@ -15816,15 +15872,15 @@
                 <a:ea typeface="Microsoft YaHei" pitchFamily="34" charset="-122"/>
                 <a:cs typeface="Microsoft YaHei" pitchFamily="34" charset="-120"/>
               </a:rPr>
-              <a:t>当前研究领域内，一些热点问题引起了广泛关注，如技术的可持续发展、环境政策的效应评估等。这些问题直接关系到社会经济的可持续发展，因此成为学术界和政策制定者关注的焦点。</a:t>
-            </a:r>
-            <a:endParaRPr lang="en-US" sz="950" dirty="0"/>
-          </a:p>
-        </p:txBody>
-      </p:sp>
-      <p:sp>
-        <p:nvSpPr>
-          <p:cNvPr id="15" name="Shape 13"/>
+              <a:t>如技术的可持续发展、环境政策的效应评估——关系社会经济可持续发展，是学界与政策制定者关注的焦点。</a:t>
+            </a:r>
+            <a:endParaRPr lang="en-US" sz="1250" dirty="0"/>
+          </a:p>
+        </p:txBody>
+      </p:sp>
+      <p:sp>
+        <p:nvSpPr>
+          <p:cNvPr id="16" name="Shape 13"/>
           <p:cNvSpPr/>
           <p:nvPr/>
         </p:nvSpPr>
@@ -15844,7 +15900,7 @@
       </p:sp>
       <p:sp>
         <p:nvSpPr>
-          <p:cNvPr id="16" name="Text 14"/>
+          <p:cNvPr id="17" name="Text 14"/>
           <p:cNvSpPr txBox="1"/>
           <p:nvPr/>
         </p:nvSpPr>
@@ -15897,7 +15953,7 @@
       </p:sp>
       <p:sp>
         <p:nvSpPr>
-          <p:cNvPr id="17" name="Text 15"/>
+          <p:cNvPr id="18" name="Text 15"/>
           <p:cNvSpPr txBox="1"/>
           <p:nvPr/>
         </p:nvSpPr>
@@ -15923,7 +15979,7 @@
               <a:buNone/>
             </a:pPr>
             <a:r>
-              <a:rPr lang="en-US" sz="950" dirty="0">
+              <a:rPr lang="en-US" sz="1250" dirty="0">
                 <a:solidFill>
                   <a:srgbClr val="2D2D2D"/>
                 </a:solidFill>
@@ -15931,15 +15987,15 @@
                 <a:ea typeface="Microsoft YaHei" pitchFamily="34" charset="-122"/>
                 <a:cs typeface="Microsoft YaHei" pitchFamily="34" charset="-120"/>
               </a:rPr>
-              <a:t>尽管研究取得了一定成果，但仍然存在数据质量、研究方法适用性等方面的不足和挑战。这些不足限制了研究的深度和广度，需要我们采取更加科学的方法和手段来解决。</a:t>
-            </a:r>
-            <a:endParaRPr lang="en-US" sz="950" dirty="0"/>
-          </a:p>
-        </p:txBody>
-      </p:sp>
-      <p:sp>
-        <p:nvSpPr>
-          <p:cNvPr id="18" name="Shape 16"/>
+              <a:t>数据质量、研究方法适用性等方面的不足，限制了研究的深度与广度，需要更科学的方法来解决。</a:t>
+            </a:r>
+            <a:endParaRPr lang="en-US" sz="1250" dirty="0"/>
+          </a:p>
+        </p:txBody>
+      </p:sp>
+      <p:sp>
+        <p:nvSpPr>
+          <p:cNvPr id="19" name="Shape 16"/>
           <p:cNvSpPr/>
           <p:nvPr/>
         </p:nvSpPr>
@@ -15959,7 +16015,7 @@
       </p:sp>
       <p:sp>
         <p:nvSpPr>
-          <p:cNvPr id="19" name="Text 17"/>
+          <p:cNvPr id="20" name="Text 17"/>
           <p:cNvSpPr txBox="1"/>
           <p:nvPr/>
         </p:nvSpPr>
@@ -16012,7 +16068,7 @@
       </p:sp>
       <p:sp>
         <p:nvSpPr>
-          <p:cNvPr id="20" name="Text 18"/>
+          <p:cNvPr id="21" name="Text 18"/>
           <p:cNvSpPr txBox="1"/>
           <p:nvPr/>
         </p:nvSpPr>
@@ -16038,7 +16094,7 @@
               <a:buNone/>
             </a:pPr>
             <a:r>
-              <a:rPr lang="en-US" sz="950" dirty="0">
+              <a:rPr lang="en-US" sz="1250" dirty="0">
                 <a:solidFill>
                   <a:srgbClr val="FFFFFF"/>
                 </a:solidFill>
@@ -16046,15 +16102,15 @@
                 <a:ea typeface="Microsoft YaHei" pitchFamily="34" charset="-122"/>
                 <a:cs typeface="Microsoft YaHei" pitchFamily="34" charset="-120"/>
               </a:rPr>
-              <a:t>随着科技进步和社会发展，研究领域呈现出一些新的趋势，例如大数据分析、跨学科研究等。这些趋势为未来研究提供了新的思路和方向。</a:t>
-            </a:r>
-            <a:endParaRPr lang="en-US" sz="950" dirty="0"/>
-          </a:p>
-        </p:txBody>
-      </p:sp>
-      <p:sp>
-        <p:nvSpPr>
-          <p:cNvPr id="21" name="Shape 19"/>
+              <a:t>大数据分析、跨学科研究等新趋势，为未来研究提供了新的思路和方向。</a:t>
+            </a:r>
+            <a:endParaRPr lang="en-US" sz="1250" dirty="0"/>
+          </a:p>
+        </p:txBody>
+      </p:sp>
+      <p:sp>
+        <p:nvSpPr>
+          <p:cNvPr id="22" name="Shape 19"/>
           <p:cNvSpPr/>
           <p:nvPr/>
         </p:nvSpPr>
@@ -16079,7 +16135,7 @@
       </p:sp>
       <p:pic>
         <p:nvPicPr>
-          <p:cNvPr id="22" name="Image 0" descr="p23_3">    </p:cNvPr>
+          <p:cNvPr id="23" name="Image 0" descr="p23_3">    </p:cNvPr>
           <p:cNvPicPr>
             <a:picLocks noChangeAspect="1"/>
           </p:cNvPicPr>
@@ -16372,7 +16428,7 @@
       </p:sp>
       <p:sp>
         <p:nvSpPr>
-          <p:cNvPr id="9" name="Shape 7"/>
+          <p:cNvPr id="10" name="Shape 7"/>
           <p:cNvSpPr/>
           <p:nvPr/>
         </p:nvSpPr>
@@ -16392,7 +16448,7 @@
       </p:sp>
       <p:sp>
         <p:nvSpPr>
-          <p:cNvPr id="10" name="Text 8"/>
+          <p:cNvPr id="11" name="Text 8"/>
           <p:cNvSpPr txBox="1"/>
           <p:nvPr/>
         </p:nvSpPr>
@@ -16431,7 +16487,7 @@
       </p:sp>
       <p:sp>
         <p:nvSpPr>
-          <p:cNvPr id="11" name="Text 9"/>
+          <p:cNvPr id="12" name="Text 9"/>
           <p:cNvSpPr txBox="1"/>
           <p:nvPr/>
         </p:nvSpPr>
@@ -16470,7 +16526,7 @@
       </p:sp>
       <p:sp>
         <p:nvSpPr>
-          <p:cNvPr id="12" name="Text 10"/>
+          <p:cNvPr id="13" name="Text 10"/>
           <p:cNvSpPr txBox="1"/>
           <p:nvPr/>
         </p:nvSpPr>
@@ -16496,7 +16552,7 @@
               <a:buNone/>
             </a:pPr>
             <a:r>
-              <a:rPr lang="en-US" sz="1100" dirty="0">
+              <a:rPr lang="en-US" sz="1400" dirty="0">
                 <a:solidFill>
                   <a:srgbClr val="2D2D2D"/>
                 </a:solidFill>
@@ -16504,15 +16560,15 @@
                 <a:ea typeface="Microsoft YaHei" pitchFamily="34" charset="-122"/>
                 <a:cs typeface="Microsoft YaHei" pitchFamily="34" charset="-120"/>
               </a:rPr>
-              <a:t>从学术角度来看，本研究有助于丰富和完善相关理论体系，为后续研究提供新的视角和理论支撑，推动学科的发展。</a:t>
-            </a:r>
-            <a:endParaRPr lang="en-US" sz="1100" dirty="0"/>
-          </a:p>
-        </p:txBody>
-      </p:sp>
-      <p:sp>
-        <p:nvSpPr>
-          <p:cNvPr id="13" name="Shape 11"/>
+              <a:t>丰富和完善相关理论体系，为后续研究提供新视角与理论支撑。</a:t>
+            </a:r>
+            <a:endParaRPr lang="en-US" sz="1400" dirty="0"/>
+          </a:p>
+        </p:txBody>
+      </p:sp>
+      <p:sp>
+        <p:nvSpPr>
+          <p:cNvPr id="14" name="Shape 11"/>
           <p:cNvSpPr/>
           <p:nvPr/>
         </p:nvSpPr>
@@ -16532,7 +16588,7 @@
       </p:sp>
       <p:sp>
         <p:nvSpPr>
-          <p:cNvPr id="14" name="Text 12"/>
+          <p:cNvPr id="15" name="Text 12"/>
           <p:cNvSpPr txBox="1"/>
           <p:nvPr/>
         </p:nvSpPr>
@@ -16571,7 +16627,7 @@
       </p:sp>
       <p:sp>
         <p:nvSpPr>
-          <p:cNvPr id="15" name="Text 13"/>
+          <p:cNvPr id="16" name="Text 13"/>
           <p:cNvSpPr txBox="1"/>
           <p:nvPr/>
         </p:nvSpPr>
@@ -16610,7 +16666,7 @@
       </p:sp>
       <p:sp>
         <p:nvSpPr>
-          <p:cNvPr id="16" name="Text 14"/>
+          <p:cNvPr id="17" name="Text 14"/>
           <p:cNvSpPr txBox="1"/>
           <p:nvPr/>
         </p:nvSpPr>
@@ -16636,7 +16692,7 @@
               <a:buNone/>
             </a:pPr>
             <a:r>
-              <a:rPr lang="en-US" sz="1100" dirty="0">
+              <a:rPr lang="en-US" sz="1400" dirty="0">
                 <a:solidFill>
                   <a:srgbClr val="2D2D2D"/>
                 </a:solidFill>
@@ -16644,15 +16700,15 @@
                 <a:ea typeface="Microsoft YaHei" pitchFamily="34" charset="-122"/>
                 <a:cs typeface="Microsoft YaHei" pitchFamily="34" charset="-120"/>
               </a:rPr>
-              <a:t>本研究在现有研究的基础上，进一步探讨了某些尚未充分研究的问题，对现有研究成果进行了补充和完善。</a:t>
-            </a:r>
-            <a:endParaRPr lang="en-US" sz="1100" dirty="0"/>
-          </a:p>
-        </p:txBody>
-      </p:sp>
-      <p:sp>
-        <p:nvSpPr>
-          <p:cNvPr id="17" name="Shape 15"/>
+              <a:t>探讨尚未充分研究的问题，补充和完善现有研究成果。</a:t>
+            </a:r>
+            <a:endParaRPr lang="en-US" sz="1400" dirty="0"/>
+          </a:p>
+        </p:txBody>
+      </p:sp>
+      <p:sp>
+        <p:nvSpPr>
+          <p:cNvPr id="18" name="Shape 15"/>
           <p:cNvSpPr/>
           <p:nvPr/>
         </p:nvSpPr>
@@ -16672,7 +16728,7 @@
       </p:sp>
       <p:sp>
         <p:nvSpPr>
-          <p:cNvPr id="18" name="Text 16"/>
+          <p:cNvPr id="19" name="Text 16"/>
           <p:cNvSpPr txBox="1"/>
           <p:nvPr/>
         </p:nvSpPr>
@@ -16711,7 +16767,7 @@
       </p:sp>
       <p:sp>
         <p:nvSpPr>
-          <p:cNvPr id="19" name="Text 17"/>
+          <p:cNvPr id="20" name="Text 17"/>
           <p:cNvSpPr txBox="1"/>
           <p:nvPr/>
         </p:nvSpPr>
@@ -16750,7 +16806,7 @@
       </p:sp>
       <p:sp>
         <p:nvSpPr>
-          <p:cNvPr id="20" name="Text 18"/>
+          <p:cNvPr id="21" name="Text 18"/>
           <p:cNvSpPr txBox="1"/>
           <p:nvPr/>
         </p:nvSpPr>
@@ -16776,7 +16832,7 @@
               <a:buNone/>
             </a:pPr>
             <a:r>
-              <a:rPr lang="en-US" sz="1100" dirty="0">
+              <a:rPr lang="en-US" sz="1400" dirty="0">
                 <a:solidFill>
                   <a:srgbClr val="2D2D2D"/>
                 </a:solidFill>
@@ -16784,15 +16840,15 @@
                 <a:ea typeface="Microsoft YaHei" pitchFamily="34" charset="-122"/>
                 <a:cs typeface="Microsoft YaHei" pitchFamily="34" charset="-120"/>
               </a:rPr>
-              <a:t>本研究的成果可直接应用于解决现实问题，如提高政策制定的科学性、促进产业的可持续发展等，具有显著的实际应用价值。</a:t>
-            </a:r>
-            <a:endParaRPr lang="en-US" sz="1100" dirty="0"/>
-          </a:p>
-        </p:txBody>
-      </p:sp>
-      <p:sp>
-        <p:nvSpPr>
-          <p:cNvPr id="21" name="Shape 19"/>
+              <a:t>直接用于解决现实问题，如提高政策制定的科学性、促进产业可持续发展。</a:t>
+            </a:r>
+            <a:endParaRPr lang="en-US" sz="1400" dirty="0"/>
+          </a:p>
+        </p:txBody>
+      </p:sp>
+      <p:sp>
+        <p:nvSpPr>
+          <p:cNvPr id="22" name="Shape 19"/>
           <p:cNvSpPr/>
           <p:nvPr/>
         </p:nvSpPr>
@@ -16812,7 +16868,7 @@
       </p:sp>
       <p:sp>
         <p:nvSpPr>
-          <p:cNvPr id="22" name="Text 20"/>
+          <p:cNvPr id="23" name="Text 20"/>
           <p:cNvSpPr txBox="1"/>
           <p:nvPr/>
         </p:nvSpPr>
@@ -16851,7 +16907,7 @@
       </p:sp>
       <p:sp>
         <p:nvSpPr>
-          <p:cNvPr id="23" name="Text 21"/>
+          <p:cNvPr id="24" name="Text 21"/>
           <p:cNvSpPr txBox="1"/>
           <p:nvPr/>
         </p:nvSpPr>
@@ -16890,7 +16946,7 @@
       </p:sp>
       <p:sp>
         <p:nvSpPr>
-          <p:cNvPr id="24" name="Text 22"/>
+          <p:cNvPr id="25" name="Text 22"/>
           <p:cNvSpPr txBox="1"/>
           <p:nvPr/>
         </p:nvSpPr>
@@ -16916,7 +16972,7 @@
               <a:buNone/>
             </a:pPr>
             <a:r>
-              <a:rPr lang="en-US" sz="1100" dirty="0">
+              <a:rPr lang="en-US" sz="1400" dirty="0">
                 <a:solidFill>
                   <a:srgbClr val="FFFFFF"/>
                 </a:solidFill>
@@ -16924,9 +16980,9 @@
                 <a:ea typeface="Microsoft YaHei" pitchFamily="34" charset="-122"/>
                 <a:cs typeface="Microsoft YaHei" pitchFamily="34" charset="-120"/>
               </a:rPr>
-              <a:t>本研究的发现和结论为未来研究提供了方向和指导，有助于学术界更好地规划后续研究工作。</a:t>
-            </a:r>
-            <a:endParaRPr lang="en-US" sz="1100" dirty="0"/>
+              <a:t>为未来研究指明方向，帮助学术界规划后续研究工作。</a:t>
+            </a:r>
+            <a:endParaRPr lang="en-US" sz="1400" dirty="0"/>
           </a:p>
         </p:txBody>
       </p:sp>
@@ -17201,7 +17257,7 @@
       </p:sp>
       <p:sp>
         <p:nvSpPr>
-          <p:cNvPr id="9" name="Shape 7"/>
+          <p:cNvPr id="10" name="Shape 7"/>
           <p:cNvSpPr/>
           <p:nvPr/>
         </p:nvSpPr>
@@ -17221,7 +17277,7 @@
       </p:sp>
       <p:sp>
         <p:nvSpPr>
-          <p:cNvPr id="10" name="Text 8"/>
+          <p:cNvPr id="11" name="Text 8"/>
           <p:cNvSpPr txBox="1"/>
           <p:nvPr/>
         </p:nvSpPr>
@@ -17260,7 +17316,7 @@
       </p:sp>
       <p:sp>
         <p:nvSpPr>
-          <p:cNvPr id="11" name="Text 9"/>
+          <p:cNvPr id="12" name="Text 9"/>
           <p:cNvSpPr txBox="1"/>
           <p:nvPr/>
         </p:nvSpPr>
@@ -17283,7 +17339,7 @@
               <a:buNone/>
             </a:pPr>
             <a:r>
-              <a:rPr lang="en-US" sz="1400" b="1" dirty="0">
+              <a:rPr lang="en-US" sz="1450" b="1" dirty="0">
                 <a:solidFill>
                   <a:srgbClr val="2D2D2D"/>
                 </a:solidFill>
@@ -17293,13 +17349,13 @@
               </a:rPr>
               <a:t>研究问题、目标设定</a:t>
             </a:r>
-            <a:endParaRPr lang="en-US" sz="1400" dirty="0"/>
-          </a:p>
-        </p:txBody>
-      </p:sp>
-      <p:sp>
-        <p:nvSpPr>
-          <p:cNvPr id="12" name="Text 10"/>
+            <a:endParaRPr lang="en-US" sz="1450" dirty="0"/>
+          </a:p>
+        </p:txBody>
+      </p:sp>
+      <p:sp>
+        <p:nvSpPr>
+          <p:cNvPr id="13" name="Text 10"/>
           <p:cNvSpPr txBox="1"/>
           <p:nvPr/>
         </p:nvSpPr>
@@ -17328,7 +17384,7 @@
               <a:buNone/>
             </a:pPr>
             <a:r>
-              <a:rPr lang="en-US" sz="1150" dirty="0">
+              <a:rPr lang="en-US" sz="1400" dirty="0">
                 <a:solidFill>
                   <a:srgbClr val="2D2D2D"/>
                 </a:solidFill>
@@ -17336,15 +17392,15 @@
                 <a:ea typeface="Microsoft YaHei" pitchFamily="34" charset="-122"/>
                 <a:cs typeface="Microsoft YaHei" pitchFamily="34" charset="-120"/>
               </a:rPr>
-              <a:t>本研究的目标是系统地分析某一领域的问题，探索其内在规律，并提出相应的解决方案，以期促进该领域的发展。</a:t>
-            </a:r>
-            <a:endParaRPr lang="en-US" sz="1150" dirty="0"/>
-          </a:p>
-        </p:txBody>
-      </p:sp>
-      <p:sp>
-        <p:nvSpPr>
-          <p:cNvPr id="13" name="Shape 11"/>
+              <a:t>系统分析某一领域的问题，探索内在规律，提出解决方案。</a:t>
+            </a:r>
+            <a:endParaRPr lang="en-US" sz="1400" dirty="0"/>
+          </a:p>
+        </p:txBody>
+      </p:sp>
+      <p:sp>
+        <p:nvSpPr>
+          <p:cNvPr id="14" name="Shape 11"/>
           <p:cNvSpPr/>
           <p:nvPr/>
         </p:nvSpPr>
@@ -17364,7 +17420,7 @@
       </p:sp>
       <p:sp>
         <p:nvSpPr>
-          <p:cNvPr id="14" name="Text 12"/>
+          <p:cNvPr id="15" name="Text 12"/>
           <p:cNvSpPr txBox="1"/>
           <p:nvPr/>
         </p:nvSpPr>
@@ -17403,7 +17459,7 @@
       </p:sp>
       <p:sp>
         <p:nvSpPr>
-          <p:cNvPr id="15" name="Text 13"/>
+          <p:cNvPr id="16" name="Text 13"/>
           <p:cNvSpPr txBox="1"/>
           <p:nvPr/>
         </p:nvSpPr>
@@ -17426,7 +17482,7 @@
               <a:buNone/>
             </a:pPr>
             <a:r>
-              <a:rPr lang="en-US" sz="1400" b="1" dirty="0">
+              <a:rPr lang="en-US" sz="1450" b="1" dirty="0">
                 <a:solidFill>
                   <a:srgbClr val="2D2D2D"/>
                 </a:solidFill>
@@ -17436,13 +17492,13 @@
               </a:rPr>
               <a:t>研究内容概括</a:t>
             </a:r>
-            <a:endParaRPr lang="en-US" sz="1400" dirty="0"/>
-          </a:p>
-        </p:txBody>
-      </p:sp>
-      <p:sp>
-        <p:nvSpPr>
-          <p:cNvPr id="16" name="Text 14"/>
+            <a:endParaRPr lang="en-US" sz="1450" dirty="0"/>
+          </a:p>
+        </p:txBody>
+      </p:sp>
+      <p:sp>
+        <p:nvSpPr>
+          <p:cNvPr id="17" name="Text 14"/>
           <p:cNvSpPr txBox="1"/>
           <p:nvPr/>
         </p:nvSpPr>
@@ -17471,7 +17527,7 @@
               <a:buNone/>
             </a:pPr>
             <a:r>
-              <a:rPr lang="en-US" sz="1150" dirty="0">
+              <a:rPr lang="en-US" sz="1400" dirty="0">
                 <a:solidFill>
                   <a:srgbClr val="2D2D2D"/>
                 </a:solidFill>
@@ -17479,15 +17535,15 @@
                 <a:ea typeface="Microsoft YaHei" pitchFamily="34" charset="-122"/>
                 <a:cs typeface="Microsoft YaHei" pitchFamily="34" charset="-120"/>
               </a:rPr>
-              <a:t>研究内容主要包括对该领域现状的分析、对热点问题的探讨、对研究方法的创新以及对未来趋势的预测等。</a:t>
-            </a:r>
-            <a:endParaRPr lang="en-US" sz="1150" dirty="0"/>
-          </a:p>
-        </p:txBody>
-      </p:sp>
-      <p:sp>
-        <p:nvSpPr>
-          <p:cNvPr id="17" name="Shape 15"/>
+              <a:t>现状分析、热点问题探讨、研究方法创新、未来趋势预测。</a:t>
+            </a:r>
+            <a:endParaRPr lang="en-US" sz="1400" dirty="0"/>
+          </a:p>
+        </p:txBody>
+      </p:sp>
+      <p:sp>
+        <p:nvSpPr>
+          <p:cNvPr id="18" name="Shape 15"/>
           <p:cNvSpPr/>
           <p:nvPr/>
         </p:nvSpPr>
@@ -17507,7 +17563,7 @@
       </p:sp>
       <p:sp>
         <p:nvSpPr>
-          <p:cNvPr id="18" name="Text 16"/>
+          <p:cNvPr id="19" name="Text 16"/>
           <p:cNvSpPr txBox="1"/>
           <p:nvPr/>
         </p:nvSpPr>
@@ -17546,7 +17602,7 @@
       </p:sp>
       <p:sp>
         <p:nvSpPr>
-          <p:cNvPr id="19" name="Text 17"/>
+          <p:cNvPr id="20" name="Text 17"/>
           <p:cNvSpPr txBox="1"/>
           <p:nvPr/>
         </p:nvSpPr>
@@ -17569,7 +17625,7 @@
               <a:buNone/>
             </a:pPr>
             <a:r>
-              <a:rPr lang="en-US" sz="1400" b="1" dirty="0">
+              <a:rPr lang="en-US" sz="1450" b="1" dirty="0">
                 <a:solidFill>
                   <a:srgbClr val="2D2D2D"/>
                 </a:solidFill>
@@ -17579,13 +17635,13 @@
               </a:rPr>
               <a:t>研究方法选择</a:t>
             </a:r>
-            <a:endParaRPr lang="en-US" sz="1400" dirty="0"/>
-          </a:p>
-        </p:txBody>
-      </p:sp>
-      <p:sp>
-        <p:nvSpPr>
-          <p:cNvPr id="20" name="Text 18"/>
+            <a:endParaRPr lang="en-US" sz="1450" dirty="0"/>
+          </a:p>
+        </p:txBody>
+      </p:sp>
+      <p:sp>
+        <p:nvSpPr>
+          <p:cNvPr id="21" name="Text 18"/>
           <p:cNvSpPr txBox="1"/>
           <p:nvPr/>
         </p:nvSpPr>
@@ -17614,7 +17670,7 @@
               <a:buNone/>
             </a:pPr>
             <a:r>
-              <a:rPr lang="en-US" sz="1150" dirty="0">
+              <a:rPr lang="en-US" sz="1400" dirty="0">
                 <a:solidFill>
                   <a:srgbClr val="2D2D2D"/>
                 </a:solidFill>
@@ -17622,15 +17678,15 @@
                 <a:ea typeface="Microsoft YaHei" pitchFamily="34" charset="-122"/>
                 <a:cs typeface="Microsoft YaHei" pitchFamily="34" charset="-120"/>
               </a:rPr>
-              <a:t>本研究采用了文献分析、实证研究、案例分析等多种研究方法，以确保研究的全面性和深入性。</a:t>
-            </a:r>
-            <a:endParaRPr lang="en-US" sz="1150" dirty="0"/>
-          </a:p>
-        </p:txBody>
-      </p:sp>
-      <p:sp>
-        <p:nvSpPr>
-          <p:cNvPr id="21" name="Shape 19"/>
+              <a:t>文献分析、实证研究、案例分析等多种方法，确保全面与深入。</a:t>
+            </a:r>
+            <a:endParaRPr lang="en-US" sz="1400" dirty="0"/>
+          </a:p>
+        </p:txBody>
+      </p:sp>
+      <p:sp>
+        <p:nvSpPr>
+          <p:cNvPr id="22" name="Shape 19"/>
           <p:cNvSpPr/>
           <p:nvPr/>
         </p:nvSpPr>
@@ -17650,7 +17706,7 @@
       </p:sp>
       <p:sp>
         <p:nvSpPr>
-          <p:cNvPr id="22" name="Text 20"/>
+          <p:cNvPr id="23" name="Text 20"/>
           <p:cNvSpPr txBox="1"/>
           <p:nvPr/>
         </p:nvSpPr>
@@ -17689,7 +17745,7 @@
       </p:sp>
       <p:sp>
         <p:nvSpPr>
-          <p:cNvPr id="23" name="Text 21"/>
+          <p:cNvPr id="24" name="Text 21"/>
           <p:cNvSpPr txBox="1"/>
           <p:nvPr/>
         </p:nvSpPr>
@@ -17712,7 +17768,7 @@
               <a:buNone/>
             </a:pPr>
             <a:r>
-              <a:rPr lang="en-US" sz="1400" b="1" dirty="0">
+              <a:rPr lang="en-US" sz="1450" b="1" dirty="0">
                 <a:solidFill>
                   <a:srgbClr val="FFFFFF"/>
                 </a:solidFill>
@@ -17722,13 +17778,13 @@
               </a:rPr>
               <a:t>研究预期成果</a:t>
             </a:r>
-            <a:endParaRPr lang="en-US" sz="1400" dirty="0"/>
-          </a:p>
-        </p:txBody>
-      </p:sp>
-      <p:sp>
-        <p:nvSpPr>
-          <p:cNvPr id="24" name="Text 22"/>
+            <a:endParaRPr lang="en-US" sz="1450" dirty="0"/>
+          </a:p>
+        </p:txBody>
+      </p:sp>
+      <p:sp>
+        <p:nvSpPr>
+          <p:cNvPr id="25" name="Text 22"/>
           <p:cNvSpPr txBox="1"/>
           <p:nvPr/>
         </p:nvSpPr>
@@ -17757,7 +17813,7 @@
               <a:buNone/>
             </a:pPr>
             <a:r>
-              <a:rPr lang="en-US" sz="1150" dirty="0">
+              <a:rPr lang="en-US" sz="1400" dirty="0">
                 <a:solidFill>
                   <a:srgbClr val="FFFFFF"/>
                 </a:solidFill>
@@ -17765,9 +17821,9 @@
                 <a:ea typeface="Microsoft YaHei" pitchFamily="34" charset="-122"/>
                 <a:cs typeface="Microsoft YaHei" pitchFamily="34" charset="-120"/>
               </a:rPr>
-              <a:t>预期通过本研究，能够提出一些有价值的观点和结论，为学术界和政策制定者提供参考。</a:t>
-            </a:r>
-            <a:endParaRPr lang="en-US" sz="1150" dirty="0"/>
+              <a:t>提出有价值的观点和结论，为学术界和政策制定者提供参考。</a:t>
+            </a:r>
+            <a:endParaRPr lang="en-US" sz="1400" dirty="0"/>
           </a:p>
         </p:txBody>
       </p:sp>
@@ -19710,7 +19766,7 @@
       </p:sp>
       <p:sp>
         <p:nvSpPr>
-          <p:cNvPr id="9" name="Text 7"/>
+          <p:cNvPr id="10" name="Text 7"/>
           <p:cNvSpPr txBox="1"/>
           <p:nvPr/>
         </p:nvSpPr>
@@ -19749,7 +19805,7 @@
       </p:sp>
       <p:sp>
         <p:nvSpPr>
-          <p:cNvPr id="10" name="Text 8"/>
+          <p:cNvPr id="11" name="Text 8"/>
           <p:cNvSpPr txBox="1"/>
           <p:nvPr/>
         </p:nvSpPr>
@@ -19788,7 +19844,7 @@
       </p:sp>
       <p:sp>
         <p:nvSpPr>
-          <p:cNvPr id="11" name="Shape 9"/>
+          <p:cNvPr id="12" name="Shape 9"/>
           <p:cNvSpPr/>
           <p:nvPr/>
         </p:nvSpPr>
@@ -19808,7 +19864,7 @@
       </p:sp>
       <p:sp>
         <p:nvSpPr>
-          <p:cNvPr id="12" name="Text 10"/>
+          <p:cNvPr id="13" name="Text 10"/>
           <p:cNvSpPr txBox="1"/>
           <p:nvPr/>
         </p:nvSpPr>
@@ -19850,7 +19906,7 @@
       </p:sp>
       <p:sp>
         <p:nvSpPr>
-          <p:cNvPr id="13" name="Text 11"/>
+          <p:cNvPr id="14" name="Text 11"/>
           <p:cNvSpPr txBox="1"/>
           <p:nvPr/>
         </p:nvSpPr>
@@ -19889,7 +19945,7 @@
       </p:sp>
       <p:sp>
         <p:nvSpPr>
-          <p:cNvPr id="14" name="Shape 12"/>
+          <p:cNvPr id="15" name="Shape 12"/>
           <p:cNvSpPr/>
           <p:nvPr/>
         </p:nvSpPr>
@@ -19909,7 +19965,7 @@
       </p:sp>
       <p:sp>
         <p:nvSpPr>
-          <p:cNvPr id="15" name="Text 13"/>
+          <p:cNvPr id="16" name="Text 13"/>
           <p:cNvSpPr txBox="1"/>
           <p:nvPr/>
         </p:nvSpPr>
@@ -19951,7 +20007,7 @@
       </p:sp>
       <p:sp>
         <p:nvSpPr>
-          <p:cNvPr id="16" name="Shape 14"/>
+          <p:cNvPr id="17" name="Shape 14"/>
           <p:cNvSpPr/>
           <p:nvPr/>
         </p:nvSpPr>
@@ -19971,7 +20027,7 @@
       </p:sp>
       <p:sp>
         <p:nvSpPr>
-          <p:cNvPr id="17" name="Text 15"/>
+          <p:cNvPr id="18" name="Text 15"/>
           <p:cNvSpPr txBox="1"/>
           <p:nvPr/>
         </p:nvSpPr>
@@ -20013,7 +20069,7 @@
       </p:sp>
       <p:sp>
         <p:nvSpPr>
-          <p:cNvPr id="18" name="Text 16"/>
+          <p:cNvPr id="19" name="Text 16"/>
           <p:cNvSpPr txBox="1"/>
           <p:nvPr/>
         </p:nvSpPr>
@@ -20052,7 +20108,7 @@
       </p:sp>
       <p:sp>
         <p:nvSpPr>
-          <p:cNvPr id="19" name="Shape 17"/>
+          <p:cNvPr id="20" name="Shape 17"/>
           <p:cNvSpPr/>
           <p:nvPr/>
         </p:nvSpPr>
@@ -20077,7 +20133,7 @@
       </p:sp>
       <p:sp>
         <p:nvSpPr>
-          <p:cNvPr id="20" name="Text 18"/>
+          <p:cNvPr id="21" name="Text 18"/>
           <p:cNvSpPr txBox="1"/>
           <p:nvPr/>
         </p:nvSpPr>
@@ -20116,7 +20172,7 @@
       </p:sp>
       <p:sp>
         <p:nvSpPr>
-          <p:cNvPr id="21" name="Shape 19"/>
+          <p:cNvPr id="22" name="Shape 19"/>
           <p:cNvSpPr/>
           <p:nvPr/>
         </p:nvSpPr>
@@ -20136,7 +20192,7 @@
       </p:sp>
       <p:sp>
         <p:nvSpPr>
-          <p:cNvPr id="22" name="Text 20"/>
+          <p:cNvPr id="23" name="Text 20"/>
           <p:cNvSpPr txBox="1"/>
           <p:nvPr/>
         </p:nvSpPr>
@@ -20178,7 +20234,7 @@
       </p:sp>
       <p:sp>
         <p:nvSpPr>
-          <p:cNvPr id="23" name="Text 21"/>
+          <p:cNvPr id="24" name="Text 21"/>
           <p:cNvSpPr txBox="1"/>
           <p:nvPr/>
         </p:nvSpPr>
@@ -20217,7 +20273,7 @@
       </p:sp>
       <p:sp>
         <p:nvSpPr>
-          <p:cNvPr id="24" name="Shape 22"/>
+          <p:cNvPr id="25" name="Shape 22"/>
           <p:cNvSpPr/>
           <p:nvPr/>
         </p:nvSpPr>
@@ -20242,7 +20298,7 @@
       </p:sp>
       <p:sp>
         <p:nvSpPr>
-          <p:cNvPr id="25" name="Text 23"/>
+          <p:cNvPr id="26" name="Text 23"/>
           <p:cNvSpPr txBox="1"/>
           <p:nvPr/>
         </p:nvSpPr>
@@ -21769,7 +21825,7 @@
       </p:sp>
       <p:sp>
         <p:nvSpPr>
-          <p:cNvPr id="9" name="Shape 7"/>
+          <p:cNvPr id="10" name="Shape 7"/>
           <p:cNvSpPr/>
           <p:nvPr/>
         </p:nvSpPr>
@@ -21789,7 +21845,7 @@
       </p:sp>
       <p:sp>
         <p:nvSpPr>
-          <p:cNvPr id="10" name="Text 8"/>
+          <p:cNvPr id="11" name="Text 8"/>
           <p:cNvSpPr txBox="1"/>
           <p:nvPr/>
         </p:nvSpPr>
@@ -21828,13 +21884,13 @@
       </p:sp>
       <p:sp>
         <p:nvSpPr>
-          <p:cNvPr id="11" name="Text 9"/>
-          <p:cNvSpPr txBox="1"/>
-          <p:nvPr/>
-        </p:nvSpPr>
-        <p:spPr>
-          <a:xfrm>
-            <a:off x="612648" y="2039112"/>
+          <p:cNvPr id="12" name="Text 9"/>
+          <p:cNvSpPr txBox="1"/>
+          <p:nvPr/>
+        </p:nvSpPr>
+        <p:spPr>
+          <a:xfrm>
+            <a:off x="612648" y="2450592"/>
             <a:ext cx="1632204" cy="365760"/>
           </a:xfrm>
           <a:prstGeom prst="rect">
@@ -21867,14 +21923,14 @@
       </p:sp>
       <p:sp>
         <p:nvSpPr>
-          <p:cNvPr id="12" name="Text 10"/>
-          <p:cNvSpPr txBox="1"/>
-          <p:nvPr/>
-        </p:nvSpPr>
-        <p:spPr>
-          <a:xfrm>
-            <a:off x="612648" y="2478024"/>
-            <a:ext cx="1613916" cy="1984248"/>
+          <p:cNvPr id="13" name="Text 10"/>
+          <p:cNvSpPr txBox="1"/>
+          <p:nvPr/>
+        </p:nvSpPr>
+        <p:spPr>
+          <a:xfrm>
+            <a:off x="612648" y="2889504"/>
+            <a:ext cx="1613916" cy="1572768"/>
           </a:xfrm>
           <a:prstGeom prst="rect">
             <a:avLst/>
@@ -21896,7 +21952,7 @@
               <a:buNone/>
             </a:pPr>
             <a:r>
-              <a:rPr lang="en-US" sz="1050" dirty="0">
+              <a:rPr lang="en-US" sz="1400" dirty="0">
                 <a:solidFill>
                   <a:srgbClr val="2D2D2D"/>
                 </a:solidFill>
@@ -21904,15 +21960,15 @@
                 <a:ea typeface="Microsoft YaHei" pitchFamily="34" charset="-122"/>
                 <a:cs typeface="Microsoft YaHei" pitchFamily="34" charset="-120"/>
               </a:rPr>
-              <a:t>如何从图书馆、数据库等渠道获取相关文献，包括书籍、期刊文章、会议论文等。搜集过程中要注意文献的权威性、时效性和相关性，确保所选文献对研究领域有实质性的贡献。</a:t>
-            </a:r>
-            <a:endParaRPr lang="en-US" sz="1050" dirty="0"/>
-          </a:p>
-        </p:txBody>
-      </p:sp>
-      <p:sp>
-        <p:nvSpPr>
-          <p:cNvPr id="13" name="Shape 11"/>
+              <a:t>从图书馆、数据库获取书籍、期刊、会议论文。关注权威性、时效性与相关性。</a:t>
+            </a:r>
+            <a:endParaRPr lang="en-US" sz="1400" dirty="0"/>
+          </a:p>
+        </p:txBody>
+      </p:sp>
+      <p:sp>
+        <p:nvSpPr>
+          <p:cNvPr id="14" name="Shape 11"/>
           <p:cNvSpPr/>
           <p:nvPr/>
         </p:nvSpPr>
@@ -21932,7 +21988,7 @@
       </p:sp>
       <p:sp>
         <p:nvSpPr>
-          <p:cNvPr id="14" name="Text 12"/>
+          <p:cNvPr id="15" name="Text 12"/>
           <p:cNvSpPr txBox="1"/>
           <p:nvPr/>
         </p:nvSpPr>
@@ -21971,13 +22027,13 @@
       </p:sp>
       <p:sp>
         <p:nvSpPr>
-          <p:cNvPr id="15" name="Text 13"/>
-          <p:cNvSpPr txBox="1"/>
-          <p:nvPr/>
-        </p:nvSpPr>
-        <p:spPr>
-          <a:xfrm>
-            <a:off x="2720340" y="2039112"/>
+          <p:cNvPr id="16" name="Text 13"/>
+          <p:cNvSpPr txBox="1"/>
+          <p:nvPr/>
+        </p:nvSpPr>
+        <p:spPr>
+          <a:xfrm>
+            <a:off x="2720340" y="2450592"/>
             <a:ext cx="1632204" cy="365760"/>
           </a:xfrm>
           <a:prstGeom prst="rect">
@@ -22010,14 +22066,14 @@
       </p:sp>
       <p:sp>
         <p:nvSpPr>
-          <p:cNvPr id="16" name="Text 14"/>
-          <p:cNvSpPr txBox="1"/>
-          <p:nvPr/>
-        </p:nvSpPr>
-        <p:spPr>
-          <a:xfrm>
-            <a:off x="2720340" y="2478024"/>
-            <a:ext cx="1613916" cy="1984248"/>
+          <p:cNvPr id="17" name="Text 14"/>
+          <p:cNvSpPr txBox="1"/>
+          <p:nvPr/>
+        </p:nvSpPr>
+        <p:spPr>
+          <a:xfrm>
+            <a:off x="2720340" y="2889504"/>
+            <a:ext cx="1613916" cy="1572768"/>
           </a:xfrm>
           <a:prstGeom prst="rect">
             <a:avLst/>
@@ -22039,7 +22095,7 @@
               <a:buNone/>
             </a:pPr>
             <a:r>
-              <a:rPr lang="en-US" sz="1050" dirty="0">
+              <a:rPr lang="en-US" sz="1400" dirty="0">
                 <a:solidFill>
                   <a:srgbClr val="2D2D2D"/>
                 </a:solidFill>
@@ -22047,15 +22103,15 @@
                 <a:ea typeface="Microsoft YaHei" pitchFamily="34" charset="-122"/>
                 <a:cs typeface="Microsoft YaHei" pitchFamily="34" charset="-120"/>
               </a:rPr>
-              <a:t>实证数据是研究背景中不可或缺的通过实验、调查问卷、统计数据等方式收集数据。在获取数据时，要注重数据的真实性和可靠性，避免数据造假或误用。</a:t>
-            </a:r>
-            <a:endParaRPr lang="en-US" sz="1050" dirty="0"/>
-          </a:p>
-        </p:txBody>
-      </p:sp>
-      <p:sp>
-        <p:nvSpPr>
-          <p:cNvPr id="17" name="Shape 15"/>
+              <a:t>通过实验、调查问卷、统计数据收集。确保真实可靠，杜绝造假或误用。</a:t>
+            </a:r>
+            <a:endParaRPr lang="en-US" sz="1400" dirty="0"/>
+          </a:p>
+        </p:txBody>
+      </p:sp>
+      <p:sp>
+        <p:nvSpPr>
+          <p:cNvPr id="18" name="Shape 15"/>
           <p:cNvSpPr/>
           <p:nvPr/>
         </p:nvSpPr>
@@ -22075,7 +22131,7 @@
       </p:sp>
       <p:sp>
         <p:nvSpPr>
-          <p:cNvPr id="18" name="Text 16"/>
+          <p:cNvPr id="19" name="Text 16"/>
           <p:cNvSpPr txBox="1"/>
           <p:nvPr/>
         </p:nvSpPr>
@@ -22114,13 +22170,13 @@
       </p:sp>
       <p:sp>
         <p:nvSpPr>
-          <p:cNvPr id="19" name="Text 17"/>
-          <p:cNvSpPr txBox="1"/>
-          <p:nvPr/>
-        </p:nvSpPr>
-        <p:spPr>
-          <a:xfrm>
-            <a:off x="4828032" y="2039112"/>
+          <p:cNvPr id="20" name="Text 17"/>
+          <p:cNvSpPr txBox="1"/>
+          <p:nvPr/>
+        </p:nvSpPr>
+        <p:spPr>
+          <a:xfrm>
+            <a:off x="4828032" y="2450592"/>
             <a:ext cx="1632204" cy="365760"/>
           </a:xfrm>
           <a:prstGeom prst="rect">
@@ -22153,14 +22209,14 @@
       </p:sp>
       <p:sp>
         <p:nvSpPr>
-          <p:cNvPr id="20" name="Text 18"/>
-          <p:cNvSpPr txBox="1"/>
-          <p:nvPr/>
-        </p:nvSpPr>
-        <p:spPr>
-          <a:xfrm>
-            <a:off x="4828032" y="2478024"/>
-            <a:ext cx="1613916" cy="1984248"/>
+          <p:cNvPr id="21" name="Text 18"/>
+          <p:cNvSpPr txBox="1"/>
+          <p:nvPr/>
+        </p:nvSpPr>
+        <p:spPr>
+          <a:xfrm>
+            <a:off x="4828032" y="2889504"/>
+            <a:ext cx="1613916" cy="1572768"/>
           </a:xfrm>
           <a:prstGeom prst="rect">
             <a:avLst/>
@@ -22182,7 +22238,7 @@
               <a:buNone/>
             </a:pPr>
             <a:r>
-              <a:rPr lang="en-US" sz="1050" dirty="0">
+              <a:rPr lang="en-US" sz="1400" dirty="0">
                 <a:solidFill>
                   <a:srgbClr val="2D2D2D"/>
                 </a:solidFill>
@@ -22190,15 +22246,15 @@
                 <a:ea typeface="Microsoft YaHei" pitchFamily="34" charset="-122"/>
                 <a:cs typeface="Microsoft YaHei" pitchFamily="34" charset="-120"/>
               </a:rPr>
-              <a:t>如何联系专家、设计访谈提纲，并从中提取有价值的信息。此外，调研过程中要注意保持客观和尊重，确保信息的准确性。</a:t>
-            </a:r>
-            <a:endParaRPr lang="en-US" sz="1050" dirty="0"/>
-          </a:p>
-        </p:txBody>
-      </p:sp>
-      <p:sp>
-        <p:nvSpPr>
-          <p:cNvPr id="21" name="Shape 19"/>
+              <a:t>联系专家、设计访谈提纲、提取有价值的信息。保持客观与尊重。</a:t>
+            </a:r>
+            <a:endParaRPr lang="en-US" sz="1400" dirty="0"/>
+          </a:p>
+        </p:txBody>
+      </p:sp>
+      <p:sp>
+        <p:nvSpPr>
+          <p:cNvPr id="22" name="Shape 19"/>
           <p:cNvSpPr/>
           <p:nvPr/>
         </p:nvSpPr>
@@ -22218,7 +22274,7 @@
       </p:sp>
       <p:sp>
         <p:nvSpPr>
-          <p:cNvPr id="22" name="Text 20"/>
+          <p:cNvPr id="23" name="Text 20"/>
           <p:cNvSpPr txBox="1"/>
           <p:nvPr/>
         </p:nvSpPr>
@@ -22257,13 +22313,13 @@
       </p:sp>
       <p:sp>
         <p:nvSpPr>
-          <p:cNvPr id="23" name="Text 21"/>
-          <p:cNvSpPr txBox="1"/>
-          <p:nvPr/>
-        </p:nvSpPr>
-        <p:spPr>
-          <a:xfrm>
-            <a:off x="6935724" y="2039112"/>
+          <p:cNvPr id="24" name="Text 21"/>
+          <p:cNvSpPr txBox="1"/>
+          <p:nvPr/>
+        </p:nvSpPr>
+        <p:spPr>
+          <a:xfrm>
+            <a:off x="6935724" y="2450592"/>
             <a:ext cx="1632204" cy="365760"/>
           </a:xfrm>
           <a:prstGeom prst="rect">
@@ -22296,14 +22352,14 @@
       </p:sp>
       <p:sp>
         <p:nvSpPr>
-          <p:cNvPr id="24" name="Text 22"/>
-          <p:cNvSpPr txBox="1"/>
-          <p:nvPr/>
-        </p:nvSpPr>
-        <p:spPr>
-          <a:xfrm>
-            <a:off x="6935724" y="2478024"/>
-            <a:ext cx="1613916" cy="1984248"/>
+          <p:cNvPr id="25" name="Text 22"/>
+          <p:cNvSpPr txBox="1"/>
+          <p:nvPr/>
+        </p:nvSpPr>
+        <p:spPr>
+          <a:xfrm>
+            <a:off x="6935724" y="2889504"/>
+            <a:ext cx="1613916" cy="1572768"/>
           </a:xfrm>
           <a:prstGeom prst="rect">
             <a:avLst/>
@@ -22325,7 +22381,7 @@
               <a:buNone/>
             </a:pPr>
             <a:r>
-              <a:rPr lang="en-US" sz="1050" dirty="0">
+              <a:rPr lang="en-US" sz="1400" dirty="0">
                 <a:solidFill>
                   <a:srgbClr val="FFFFFF"/>
                 </a:solidFill>
@@ -22333,9 +22389,9 @@
                 <a:ea typeface="Microsoft YaHei" pitchFamily="34" charset="-122"/>
                 <a:cs typeface="Microsoft YaHei" pitchFamily="34" charset="-120"/>
               </a:rPr>
-              <a:t>筛选和评估网络资源，包括学术论文、专业网站、在线数据库等。同时，要教育学生识别网络上的不实信息和伪科学内容，避免误导。</a:t>
-            </a:r>
-            <a:endParaRPr lang="en-US" sz="1050" dirty="0"/>
+              <a:t>筛选学术论文、专业网站、在线数据库。识别不实信息与伪科学内容。</a:t>
+            </a:r>
+            <a:endParaRPr lang="en-US" sz="1400" dirty="0"/>
           </a:p>
         </p:txBody>
       </p:sp>
@@ -22610,7 +22666,7 @@
       </p:sp>
       <p:sp>
         <p:nvSpPr>
-          <p:cNvPr id="9" name="Shape 7"/>
+          <p:cNvPr id="10" name="Shape 7"/>
           <p:cNvSpPr/>
           <p:nvPr/>
         </p:nvSpPr>
@@ -22630,7 +22686,7 @@
       </p:sp>
       <p:sp>
         <p:nvSpPr>
-          <p:cNvPr id="10" name="Text 8"/>
+          <p:cNvPr id="11" name="Text 8"/>
           <p:cNvSpPr txBox="1"/>
           <p:nvPr/>
         </p:nvSpPr>
@@ -22669,7 +22725,7 @@
       </p:sp>
       <p:sp>
         <p:nvSpPr>
-          <p:cNvPr id="11" name="Text 9"/>
+          <p:cNvPr id="12" name="Text 9"/>
           <p:cNvSpPr txBox="1"/>
           <p:nvPr/>
         </p:nvSpPr>
@@ -22708,7 +22764,7 @@
       </p:sp>
       <p:sp>
         <p:nvSpPr>
-          <p:cNvPr id="12" name="Text 10"/>
+          <p:cNvPr id="13" name="Text 10"/>
           <p:cNvSpPr txBox="1"/>
           <p:nvPr/>
         </p:nvSpPr>
@@ -22734,7 +22790,7 @@
               <a:buNone/>
             </a:pPr>
             <a:r>
-              <a:rPr lang="en-US" sz="1100" dirty="0">
+              <a:rPr lang="en-US" sz="1400" dirty="0">
                 <a:solidFill>
                   <a:srgbClr val="2D2D2D"/>
                 </a:solidFill>
@@ -22742,15 +22798,15 @@
                 <a:ea typeface="Microsoft YaHei" pitchFamily="34" charset="-122"/>
                 <a:cs typeface="Microsoft YaHei" pitchFamily="34" charset="-120"/>
               </a:rPr>
-              <a:t>按照类型、主题、来源等分类。分类工作有助于后续的分析和处理，使资料更加条理化。</a:t>
-            </a:r>
-            <a:endParaRPr lang="en-US" sz="1100" dirty="0"/>
-          </a:p>
-        </p:txBody>
-      </p:sp>
-      <p:sp>
-        <p:nvSpPr>
-          <p:cNvPr id="13" name="Shape 11"/>
+              <a:t>按类型、主题、来源分类，使资料条理化，便于后续分析。</a:t>
+            </a:r>
+            <a:endParaRPr lang="en-US" sz="1400" dirty="0"/>
+          </a:p>
+        </p:txBody>
+      </p:sp>
+      <p:sp>
+        <p:nvSpPr>
+          <p:cNvPr id="14" name="Shape 11"/>
           <p:cNvSpPr/>
           <p:nvPr/>
         </p:nvSpPr>
@@ -22770,7 +22826,7 @@
       </p:sp>
       <p:sp>
         <p:nvSpPr>
-          <p:cNvPr id="14" name="Text 12"/>
+          <p:cNvPr id="15" name="Text 12"/>
           <p:cNvSpPr txBox="1"/>
           <p:nvPr/>
         </p:nvSpPr>
@@ -22809,7 +22865,7 @@
       </p:sp>
       <p:sp>
         <p:nvSpPr>
-          <p:cNvPr id="15" name="Text 13"/>
+          <p:cNvPr id="16" name="Text 13"/>
           <p:cNvSpPr txBox="1"/>
           <p:nvPr/>
         </p:nvSpPr>
@@ -22848,7 +22904,7 @@
       </p:sp>
       <p:sp>
         <p:nvSpPr>
-          <p:cNvPr id="16" name="Text 14"/>
+          <p:cNvPr id="17" name="Text 14"/>
           <p:cNvSpPr txBox="1"/>
           <p:nvPr/>
         </p:nvSpPr>
@@ -22874,7 +22930,7 @@
               <a:buNone/>
             </a:pPr>
             <a:r>
-              <a:rPr lang="en-US" sz="1100" dirty="0">
+              <a:rPr lang="en-US" sz="1400" dirty="0">
                 <a:solidFill>
                   <a:srgbClr val="2D2D2D"/>
                 </a:solidFill>
@@ -22882,15 +22938,15 @@
                 <a:ea typeface="Microsoft YaHei" pitchFamily="34" charset="-122"/>
                 <a:cs typeface="Microsoft YaHei" pitchFamily="34" charset="-120"/>
               </a:rPr>
-              <a:t>分析资料与研究主题的相关性，筛选出与研究密切相关的资料，剔除无关或弱相关的资料。相关性分析有助于提高研究的针对性和有效性。</a:t>
-            </a:r>
-            <a:endParaRPr lang="en-US" sz="1100" dirty="0"/>
-          </a:p>
-        </p:txBody>
-      </p:sp>
-      <p:sp>
-        <p:nvSpPr>
-          <p:cNvPr id="17" name="Shape 15"/>
+              <a:t>保留与主题密切相关的资料，剔除无关或弱相关内容。</a:t>
+            </a:r>
+            <a:endParaRPr lang="en-US" sz="1400" dirty="0"/>
+          </a:p>
+        </p:txBody>
+      </p:sp>
+      <p:sp>
+        <p:nvSpPr>
+          <p:cNvPr id="18" name="Shape 15"/>
           <p:cNvSpPr/>
           <p:nvPr/>
         </p:nvSpPr>
@@ -22910,7 +22966,7 @@
       </p:sp>
       <p:sp>
         <p:nvSpPr>
-          <p:cNvPr id="18" name="Text 16"/>
+          <p:cNvPr id="19" name="Text 16"/>
           <p:cNvSpPr txBox="1"/>
           <p:nvPr/>
         </p:nvSpPr>
@@ -22949,7 +23005,7 @@
       </p:sp>
       <p:sp>
         <p:nvSpPr>
-          <p:cNvPr id="19" name="Text 17"/>
+          <p:cNvPr id="20" name="Text 17"/>
           <p:cNvSpPr txBox="1"/>
           <p:nvPr/>
         </p:nvSpPr>
@@ -22988,7 +23044,7 @@
       </p:sp>
       <p:sp>
         <p:nvSpPr>
-          <p:cNvPr id="20" name="Text 18"/>
+          <p:cNvPr id="21" name="Text 18"/>
           <p:cNvSpPr txBox="1"/>
           <p:nvPr/>
         </p:nvSpPr>
@@ -23014,7 +23070,7 @@
               <a:buNone/>
             </a:pPr>
             <a:r>
-              <a:rPr lang="en-US" sz="1100" dirty="0">
+              <a:rPr lang="en-US" sz="1400" dirty="0">
                 <a:solidFill>
                   <a:srgbClr val="2D2D2D"/>
                 </a:solidFill>
@@ -23022,15 +23078,15 @@
                 <a:ea typeface="Microsoft YaHei" pitchFamily="34" charset="-122"/>
                 <a:cs typeface="Microsoft YaHei" pitchFamily="34" charset="-120"/>
               </a:rPr>
-              <a:t>评估资料的可信度，包括作者资质、出版机构、引用频次等。通过评估，确保使用的是可靠和权威的资料，增强研究的可信度。</a:t>
-            </a:r>
-            <a:endParaRPr lang="en-US" sz="1100" dirty="0"/>
-          </a:p>
-        </p:txBody>
-      </p:sp>
-      <p:sp>
-        <p:nvSpPr>
-          <p:cNvPr id="21" name="Shape 19"/>
+              <a:t>考察作者资质、出版机构、引用频次，确保资料可靠权威。</a:t>
+            </a:r>
+            <a:endParaRPr lang="en-US" sz="1400" dirty="0"/>
+          </a:p>
+        </p:txBody>
+      </p:sp>
+      <p:sp>
+        <p:nvSpPr>
+          <p:cNvPr id="22" name="Shape 19"/>
           <p:cNvSpPr/>
           <p:nvPr/>
         </p:nvSpPr>
@@ -23050,7 +23106,7 @@
       </p:sp>
       <p:sp>
         <p:nvSpPr>
-          <p:cNvPr id="22" name="Text 20"/>
+          <p:cNvPr id="23" name="Text 20"/>
           <p:cNvSpPr txBox="1"/>
           <p:nvPr/>
         </p:nvSpPr>
@@ -23089,7 +23145,7 @@
       </p:sp>
       <p:sp>
         <p:nvSpPr>
-          <p:cNvPr id="23" name="Text 21"/>
+          <p:cNvPr id="24" name="Text 21"/>
           <p:cNvSpPr txBox="1"/>
           <p:nvPr/>
         </p:nvSpPr>
@@ -23128,7 +23184,7 @@
       </p:sp>
       <p:sp>
         <p:nvSpPr>
-          <p:cNvPr id="24" name="Text 22"/>
+          <p:cNvPr id="25" name="Text 22"/>
           <p:cNvSpPr txBox="1"/>
           <p:nvPr/>
         </p:nvSpPr>
@@ -23154,7 +23210,7 @@
               <a:buNone/>
             </a:pPr>
             <a:r>
-              <a:rPr lang="en-US" sz="1100" dirty="0">
+              <a:rPr lang="en-US" sz="1400" dirty="0">
                 <a:solidFill>
                   <a:srgbClr val="FFFFFF"/>
                 </a:solidFill>
@@ -23162,9 +23218,9 @@
                 <a:ea typeface="Microsoft YaHei" pitchFamily="34" charset="-122"/>
                 <a:cs typeface="Microsoft YaHei" pitchFamily="34" charset="-120"/>
               </a:rPr>
-              <a:t>将搜集到的资料综合运用到研究背景中，包括资料的引用、整合和对比分析等。综合运用资料可以使研究背景更加丰富和立体。</a:t>
-            </a:r>
-            <a:endParaRPr lang="en-US" sz="1100" dirty="0"/>
+              <a:t>通过引用、整合与对比分析，让研究背景丰富而立体。</a:t>
+            </a:r>
+            <a:endParaRPr lang="en-US" sz="1400" dirty="0"/>
           </a:p>
         </p:txBody>
       </p:sp>
@@ -24798,7 +24854,7 @@
       </p:sp>
       <p:sp>
         <p:nvSpPr>
-          <p:cNvPr id="9" name="Shape 7"/>
+          <p:cNvPr id="10" name="Shape 7"/>
           <p:cNvSpPr/>
           <p:nvPr/>
         </p:nvSpPr>
@@ -24818,7 +24874,7 @@
       </p:sp>
       <p:sp>
         <p:nvSpPr>
-          <p:cNvPr id="10" name="Text 8"/>
+          <p:cNvPr id="11" name="Text 8"/>
           <p:cNvSpPr txBox="1"/>
           <p:nvPr/>
         </p:nvSpPr>
@@ -24857,7 +24913,7 @@
       </p:sp>
       <p:sp>
         <p:nvSpPr>
-          <p:cNvPr id="11" name="Text 9"/>
+          <p:cNvPr id="12" name="Text 9"/>
           <p:cNvSpPr txBox="1"/>
           <p:nvPr/>
         </p:nvSpPr>
@@ -24896,7 +24952,7 @@
       </p:sp>
       <p:sp>
         <p:nvSpPr>
-          <p:cNvPr id="12" name="Shape 10"/>
+          <p:cNvPr id="13" name="Shape 10"/>
           <p:cNvSpPr/>
           <p:nvPr/>
         </p:nvSpPr>
@@ -24916,7 +24972,7 @@
       </p:sp>
       <p:sp>
         <p:nvSpPr>
-          <p:cNvPr id="13" name="Text 11"/>
+          <p:cNvPr id="14" name="Text 11"/>
           <p:cNvSpPr txBox="1"/>
           <p:nvPr/>
         </p:nvSpPr>
@@ -24942,7 +24998,7 @@
               <a:buNone/>
             </a:pPr>
             <a:r>
-              <a:rPr lang="en-US" sz="1500" dirty="0">
+              <a:rPr lang="en-US" sz="1700" dirty="0">
                 <a:solidFill>
                   <a:srgbClr val="2D2D2D"/>
                 </a:solidFill>
@@ -24950,9 +25006,9 @@
                 <a:ea typeface="Microsoft YaHei" pitchFamily="34" charset="-122"/>
                 <a:cs typeface="Microsoft YaHei" pitchFamily="34" charset="-120"/>
               </a:rPr>
-              <a:t>在撰写研究背景时，需要梳理出一条贯穿全文的主线，这条主线通常围绕研究的核心问题展开。通过梳理主线，教师可以更好地引导读者理解研究的重要性，以及研究内容与主题之间的紧密联系。</a:t>
-            </a:r>
-            <a:endParaRPr lang="en-US" sz="1500" dirty="0"/>
+              <a:t>围绕研究的核心问题，梳理一条贯穿全文的主线——引导读者理解研究的重要性，以及研究内容与主题之间的紧密联系。</a:t>
+            </a:r>
+            <a:endParaRPr lang="en-US" sz="1700" dirty="0"/>
           </a:p>
         </p:txBody>
       </p:sp>
@@ -25227,7 +25283,7 @@
       </p:sp>
       <p:sp>
         <p:nvSpPr>
-          <p:cNvPr id="9" name="Shape 7"/>
+          <p:cNvPr id="10" name="Shape 7"/>
           <p:cNvSpPr/>
           <p:nvPr/>
         </p:nvSpPr>
@@ -25247,7 +25303,7 @@
       </p:sp>
       <p:sp>
         <p:nvSpPr>
-          <p:cNvPr id="10" name="Text 8"/>
+          <p:cNvPr id="11" name="Text 8"/>
           <p:cNvSpPr txBox="1"/>
           <p:nvPr/>
         </p:nvSpPr>
@@ -25286,7 +25342,7 @@
       </p:sp>
       <p:sp>
         <p:nvSpPr>
-          <p:cNvPr id="11" name="Shape 9"/>
+          <p:cNvPr id="12" name="Shape 9"/>
           <p:cNvSpPr/>
           <p:nvPr/>
         </p:nvSpPr>
@@ -25306,7 +25362,7 @@
       </p:sp>
       <p:sp>
         <p:nvSpPr>
-          <p:cNvPr id="12" name="Text 10"/>
+          <p:cNvPr id="13" name="Text 10"/>
           <p:cNvSpPr txBox="1"/>
           <p:nvPr/>
         </p:nvSpPr>
@@ -25345,7 +25401,7 @@
       </p:sp>
       <p:sp>
         <p:nvSpPr>
-          <p:cNvPr id="13" name="Shape 11"/>
+          <p:cNvPr id="14" name="Shape 11"/>
           <p:cNvSpPr/>
           <p:nvPr/>
         </p:nvSpPr>
@@ -25365,7 +25421,7 @@
       </p:sp>
       <p:sp>
         <p:nvSpPr>
-          <p:cNvPr id="14" name="Text 12"/>
+          <p:cNvPr id="15" name="Text 12"/>
           <p:cNvSpPr txBox="1"/>
           <p:nvPr/>
         </p:nvSpPr>
@@ -25404,7 +25460,7 @@
       </p:sp>
       <p:sp>
         <p:nvSpPr>
-          <p:cNvPr id="15" name="Shape 13"/>
+          <p:cNvPr id="16" name="Shape 13"/>
           <p:cNvSpPr/>
           <p:nvPr/>
         </p:nvSpPr>
@@ -25424,7 +25480,7 @@
       </p:sp>
       <p:sp>
         <p:nvSpPr>
-          <p:cNvPr id="16" name="Text 14"/>
+          <p:cNvPr id="17" name="Text 14"/>
           <p:cNvSpPr txBox="1"/>
           <p:nvPr/>
         </p:nvSpPr>
@@ -25463,7 +25519,7 @@
       </p:sp>
       <p:sp>
         <p:nvSpPr>
-          <p:cNvPr id="17" name="Shape 15"/>
+          <p:cNvPr id="18" name="Shape 15"/>
           <p:cNvSpPr/>
           <p:nvPr/>
         </p:nvSpPr>
@@ -25483,7 +25539,7 @@
       </p:sp>
       <p:sp>
         <p:nvSpPr>
-          <p:cNvPr id="18" name="Text 16"/>
+          <p:cNvPr id="19" name="Text 16"/>
           <p:cNvSpPr txBox="1"/>
           <p:nvPr/>
         </p:nvSpPr>
@@ -25522,14 +25578,14 @@
       </p:sp>
       <p:sp>
         <p:nvSpPr>
-          <p:cNvPr id="19" name="Text 17"/>
-          <p:cNvSpPr txBox="1"/>
-          <p:nvPr/>
-        </p:nvSpPr>
-        <p:spPr>
-          <a:xfrm>
-            <a:off x="594360" y="2560320"/>
-            <a:ext cx="1677924" cy="1965960"/>
+          <p:cNvPr id="20" name="Text 17"/>
+          <p:cNvSpPr txBox="1"/>
+          <p:nvPr/>
+        </p:nvSpPr>
+        <p:spPr>
+          <a:xfrm>
+            <a:off x="594360" y="2606040"/>
+            <a:ext cx="1677924" cy="1920240"/>
           </a:xfrm>
           <a:prstGeom prst="rect">
             <a:avLst/>
@@ -25543,12 +25599,12 @@
           <a:p>
             <a:pPr indent="0" marL="0">
               <a:lnSpc>
-                <a:spcPct val="130000"/>
+                <a:spcPct val="140000"/>
               </a:lnSpc>
               <a:buNone/>
             </a:pPr>
             <a:r>
-              <a:rPr lang="en-US" sz="950" dirty="0">
+              <a:rPr lang="en-US" sz="1350" dirty="0">
                 <a:solidFill>
                   <a:srgbClr val="2D2D2D"/>
                 </a:solidFill>
@@ -25556,15 +25612,15 @@
                 <a:ea typeface="Microsoft YaHei" pitchFamily="34" charset="-122"/>
                 <a:cs typeface="Microsoft YaHei" pitchFamily="34" charset="-120"/>
               </a:rPr>
-              <a:t>在研究背景中，信息分类是指将收集到的资料按照类型、来源或重要性进行分类整理。这种分类有助于教师清晰地识别和组织信息，使背景内容更加有条理性和系统性。</a:t>
-            </a:r>
-            <a:endParaRPr lang="en-US" sz="950" dirty="0"/>
-          </a:p>
-        </p:txBody>
-      </p:sp>
-      <p:sp>
-        <p:nvSpPr>
-          <p:cNvPr id="20" name="Shape 18"/>
+              <a:t>按类型、来源或重要性整理资料，使背景内容有条理、成体系。</a:t>
+            </a:r>
+            <a:endParaRPr lang="en-US" sz="1350" dirty="0"/>
+          </a:p>
+        </p:txBody>
+      </p:sp>
+      <p:sp>
+        <p:nvSpPr>
+          <p:cNvPr id="21" name="Shape 18"/>
           <p:cNvSpPr/>
           <p:nvPr/>
         </p:nvSpPr>
@@ -25584,7 +25640,7 @@
       </p:sp>
       <p:sp>
         <p:nvSpPr>
-          <p:cNvPr id="21" name="Text 19"/>
+          <p:cNvPr id="22" name="Text 19"/>
           <p:cNvSpPr txBox="1"/>
           <p:nvPr/>
         </p:nvSpPr>
@@ -25623,14 +25679,14 @@
       </p:sp>
       <p:sp>
         <p:nvSpPr>
-          <p:cNvPr id="22" name="Text 20"/>
-          <p:cNvSpPr txBox="1"/>
-          <p:nvPr/>
-        </p:nvSpPr>
-        <p:spPr>
-          <a:xfrm>
-            <a:off x="2702052" y="2560320"/>
-            <a:ext cx="1677924" cy="1965960"/>
+          <p:cNvPr id="23" name="Text 20"/>
+          <p:cNvSpPr txBox="1"/>
+          <p:nvPr/>
+        </p:nvSpPr>
+        <p:spPr>
+          <a:xfrm>
+            <a:off x="2702052" y="2606040"/>
+            <a:ext cx="1677924" cy="1920240"/>
           </a:xfrm>
           <a:prstGeom prst="rect">
             <a:avLst/>
@@ -25644,12 +25700,12 @@
           <a:p>
             <a:pPr indent="0" marL="0">
               <a:lnSpc>
-                <a:spcPct val="130000"/>
+                <a:spcPct val="140000"/>
               </a:lnSpc>
               <a:buNone/>
             </a:pPr>
             <a:r>
-              <a:rPr lang="en-US" sz="950" dirty="0">
+              <a:rPr lang="en-US" sz="1350" dirty="0">
                 <a:solidFill>
                   <a:srgbClr val="2D2D2D"/>
                 </a:solidFill>
@@ -25657,15 +25713,15 @@
                 <a:ea typeface="Microsoft YaHei" pitchFamily="34" charset="-122"/>
                 <a:cs typeface="Microsoft YaHei" pitchFamily="34" charset="-120"/>
               </a:rPr>
-              <a:t>条理清晰度是指研究背景的表述是否清晰易懂，是否能够使教师一目了然地理解研究背景的全貌。这需要教师在撰写时注重语言的简练、逻辑的清晰，避免冗余和模糊的表述。</a:t>
-            </a:r>
-            <a:endParaRPr lang="en-US" sz="950" dirty="0"/>
-          </a:p>
-        </p:txBody>
-      </p:sp>
-      <p:sp>
-        <p:nvSpPr>
-          <p:cNvPr id="23" name="Shape 21"/>
+              <a:t>语言简练、逻辑清晰，让读者一目了然地把握研究背景的全貌。</a:t>
+            </a:r>
+            <a:endParaRPr lang="en-US" sz="1350" dirty="0"/>
+          </a:p>
+        </p:txBody>
+      </p:sp>
+      <p:sp>
+        <p:nvSpPr>
+          <p:cNvPr id="24" name="Shape 21"/>
           <p:cNvSpPr/>
           <p:nvPr/>
         </p:nvSpPr>
@@ -25685,7 +25741,7 @@
       </p:sp>
       <p:sp>
         <p:nvSpPr>
-          <p:cNvPr id="24" name="Text 22"/>
+          <p:cNvPr id="25" name="Text 22"/>
           <p:cNvSpPr txBox="1"/>
           <p:nvPr/>
         </p:nvSpPr>
@@ -25724,14 +25780,14 @@
       </p:sp>
       <p:sp>
         <p:nvSpPr>
-          <p:cNvPr id="25" name="Text 23"/>
-          <p:cNvSpPr txBox="1"/>
-          <p:nvPr/>
-        </p:nvSpPr>
-        <p:spPr>
-          <a:xfrm>
-            <a:off x="4809744" y="2560320"/>
-            <a:ext cx="1677924" cy="1965960"/>
+          <p:cNvPr id="26" name="Text 23"/>
+          <p:cNvSpPr txBox="1"/>
+          <p:nvPr/>
+        </p:nvSpPr>
+        <p:spPr>
+          <a:xfrm>
+            <a:off x="4809744" y="2606040"/>
+            <a:ext cx="1677924" cy="1920240"/>
           </a:xfrm>
           <a:prstGeom prst="rect">
             <a:avLst/>
@@ -25745,12 +25801,12 @@
           <a:p>
             <a:pPr indent="0" marL="0">
               <a:lnSpc>
-                <a:spcPct val="130000"/>
+                <a:spcPct val="140000"/>
               </a:lnSpc>
               <a:buNone/>
             </a:pPr>
             <a:r>
-              <a:rPr lang="en-US" sz="950" dirty="0">
+              <a:rPr lang="en-US" sz="1350" dirty="0">
                 <a:solidFill>
                   <a:srgbClr val="2D2D2D"/>
                 </a:solidFill>
@@ -25758,15 +25814,15 @@
                 <a:ea typeface="Microsoft YaHei" pitchFamily="34" charset="-122"/>
                 <a:cs typeface="Microsoft YaHei" pitchFamily="34" charset="-120"/>
               </a:rPr>
-              <a:t>连贯性是指研究背景中的信息、观点和论证是否形成一个连续、统一的整体。教师应当确保各部分内容相互关联，相互支撑，避免出现跳跃和断裂，使背景内容更加协调一致。</a:t>
-            </a:r>
-            <a:endParaRPr lang="en-US" sz="950" dirty="0"/>
-          </a:p>
-        </p:txBody>
-      </p:sp>
-      <p:sp>
-        <p:nvSpPr>
-          <p:cNvPr id="26" name="Shape 24"/>
+              <a:t>信息、观点与论证相互关联、相互支撑，避免跳跃和断裂。</a:t>
+            </a:r>
+            <a:endParaRPr lang="en-US" sz="1350" dirty="0"/>
+          </a:p>
+        </p:txBody>
+      </p:sp>
+      <p:sp>
+        <p:nvSpPr>
+          <p:cNvPr id="27" name="Shape 24"/>
           <p:cNvSpPr/>
           <p:nvPr/>
         </p:nvSpPr>
@@ -25786,7 +25842,7 @@
       </p:sp>
       <p:sp>
         <p:nvSpPr>
-          <p:cNvPr id="27" name="Text 25"/>
+          <p:cNvPr id="28" name="Text 25"/>
           <p:cNvSpPr txBox="1"/>
           <p:nvPr/>
         </p:nvSpPr>
@@ -25825,14 +25881,14 @@
       </p:sp>
       <p:sp>
         <p:nvSpPr>
-          <p:cNvPr id="28" name="Text 26"/>
-          <p:cNvSpPr txBox="1"/>
-          <p:nvPr/>
-        </p:nvSpPr>
-        <p:spPr>
-          <a:xfrm>
-            <a:off x="6917436" y="2560320"/>
-            <a:ext cx="1677924" cy="1965960"/>
+          <p:cNvPr id="29" name="Text 26"/>
+          <p:cNvSpPr txBox="1"/>
+          <p:nvPr/>
+        </p:nvSpPr>
+        <p:spPr>
+          <a:xfrm>
+            <a:off x="6917436" y="2606040"/>
+            <a:ext cx="1677924" cy="1920240"/>
           </a:xfrm>
           <a:prstGeom prst="rect">
             <a:avLst/>
@@ -25846,12 +25902,12 @@
           <a:p>
             <a:pPr indent="0" marL="0">
               <a:lnSpc>
-                <a:spcPct val="130000"/>
+                <a:spcPct val="140000"/>
               </a:lnSpc>
               <a:buNone/>
             </a:pPr>
             <a:r>
-              <a:rPr lang="en-US" sz="950" dirty="0">
+              <a:rPr lang="en-US" sz="1350" dirty="0">
                 <a:solidFill>
                   <a:srgbClr val="2D2D2D"/>
                 </a:solidFill>
@@ -25859,9 +25915,9 @@
                 <a:ea typeface="Microsoft YaHei" pitchFamily="34" charset="-122"/>
                 <a:cs typeface="Microsoft YaHei" pitchFamily="34" charset="-120"/>
               </a:rPr>
-              <a:t>易读性是指研究背景是否易于阅读和理解。教师应当在撰写时考虑到读者的背景知识，使用恰当的术语和表达方式，使内容既专业又易于接受，以便于读者快速把握研究背景的核心信息。</a:t>
-            </a:r>
-            <a:endParaRPr lang="en-US" sz="950" dirty="0"/>
+              <a:t>考虑读者的背景知识，术语恰当，内容既专业又易于接受。</a:t>
+            </a:r>
+            <a:endParaRPr lang="en-US" sz="1350" dirty="0"/>
           </a:p>
         </p:txBody>
       </p:sp>
@@ -27494,7 +27550,7 @@
       </p:sp>
       <p:sp>
         <p:nvSpPr>
-          <p:cNvPr id="9" name="Text 7"/>
+          <p:cNvPr id="10" name="Text 7"/>
           <p:cNvSpPr txBox="1"/>
           <p:nvPr/>
         </p:nvSpPr>
@@ -27533,7 +27589,7 @@
       </p:sp>
       <p:sp>
         <p:nvSpPr>
-          <p:cNvPr id="10" name="Shape 8"/>
+          <p:cNvPr id="11" name="Shape 8"/>
           <p:cNvSpPr/>
           <p:nvPr/>
         </p:nvSpPr>
@@ -27553,7 +27609,7 @@
       </p:sp>
       <p:sp>
         <p:nvSpPr>
-          <p:cNvPr id="11" name="Text 9"/>
+          <p:cNvPr id="12" name="Text 9"/>
           <p:cNvSpPr txBox="1"/>
           <p:nvPr/>
         </p:nvSpPr>
@@ -27592,7 +27648,7 @@
       </p:sp>
       <p:sp>
         <p:nvSpPr>
-          <p:cNvPr id="12" name="Text 10"/>
+          <p:cNvPr id="13" name="Text 10"/>
           <p:cNvSpPr txBox="1"/>
           <p:nvPr/>
         </p:nvSpPr>
@@ -27613,12 +27669,12 @@
           <a:p>
             <a:pPr indent="0" marL="0">
               <a:lnSpc>
-                <a:spcPct val="145000"/>
+                <a:spcPct val="150000"/>
               </a:lnSpc>
               <a:buNone/>
             </a:pPr>
             <a:r>
-              <a:rPr lang="en-US" sz="1200" dirty="0">
+              <a:rPr lang="en-US" sz="1400" dirty="0">
                 <a:solidFill>
                   <a:srgbClr val="2D2D2D"/>
                 </a:solidFill>
@@ -27626,15 +27682,15 @@
                 <a:ea typeface="Microsoft YaHei" pitchFamily="34" charset="-122"/>
                 <a:cs typeface="Microsoft YaHei" pitchFamily="34" charset="-120"/>
               </a:rPr>
-              <a:t>图表类型的选择应基于数据的特点和需要展示的信息。例如，对于趋势分析，折线图可能是最佳选择；而对于比较不同组的数据，条形图或饼图可能更为合适。</a:t>
-            </a:r>
-            <a:endParaRPr lang="en-US" sz="1200" dirty="0"/>
-          </a:p>
-        </p:txBody>
-      </p:sp>
-      <p:sp>
-        <p:nvSpPr>
-          <p:cNvPr id="13" name="Shape 11"/>
+              <a:t>根据数据特点和要展示的信息选择图表：趋势分析用折线图；比较不同组的数据用条形图或饼图。</a:t>
+            </a:r>
+            <a:endParaRPr lang="en-US" sz="1400" dirty="0"/>
+          </a:p>
+        </p:txBody>
+      </p:sp>
+      <p:sp>
+        <p:nvSpPr>
+          <p:cNvPr id="14" name="Shape 11"/>
           <p:cNvSpPr/>
           <p:nvPr/>
         </p:nvSpPr>
@@ -27654,7 +27710,7 @@
       </p:sp>
       <p:graphicFrame>
         <p:nvGraphicFramePr>
-          <p:cNvPr id="14" name="Chart 0" descr=""/>
+          <p:cNvPr id="15" name="Chart 0" descr=""/>
           <p:cNvGraphicFramePr/>
           <p:nvPr/>
         </p:nvGraphicFramePr>
@@ -27670,7 +27726,7 @@
       </p:graphicFrame>
       <p:sp>
         <p:nvSpPr>
-          <p:cNvPr id="15" name="Text 12"/>
+          <p:cNvPr id="16" name="Text 12"/>
           <p:cNvSpPr txBox="1"/>
           <p:nvPr/>
         </p:nvSpPr>
@@ -27709,7 +27765,7 @@
       </p:sp>
       <p:sp>
         <p:nvSpPr>
-          <p:cNvPr id="16" name="Text 13"/>
+          <p:cNvPr id="17" name="Text 13"/>
           <p:cNvSpPr txBox="1"/>
           <p:nvPr/>
         </p:nvSpPr>
@@ -27748,7 +27804,7 @@
       </p:sp>
       <p:sp>
         <p:nvSpPr>
-          <p:cNvPr id="17" name="Shape 14"/>
+          <p:cNvPr id="18" name="Shape 14"/>
           <p:cNvSpPr/>
           <p:nvPr/>
         </p:nvSpPr>
@@ -27768,7 +27824,7 @@
       </p:sp>
       <p:graphicFrame>
         <p:nvGraphicFramePr>
-          <p:cNvPr id="18" name="Chart 1" descr=""/>
+          <p:cNvPr id="19" name="Chart 1" descr=""/>
           <p:cNvGraphicFramePr/>
           <p:nvPr/>
         </p:nvGraphicFramePr>
@@ -27784,7 +27840,7 @@
       </p:graphicFrame>
       <p:sp>
         <p:nvSpPr>
-          <p:cNvPr id="19" name="Text 15"/>
+          <p:cNvPr id="20" name="Text 15"/>
           <p:cNvSpPr txBox="1"/>
           <p:nvPr/>
         </p:nvSpPr>
@@ -27823,7 +27879,7 @@
       </p:sp>
       <p:sp>
         <p:nvSpPr>
-          <p:cNvPr id="20" name="Text 16"/>
+          <p:cNvPr id="21" name="Text 16"/>
           <p:cNvSpPr txBox="1"/>
           <p:nvPr/>
         </p:nvSpPr>
@@ -27862,7 +27918,7 @@
       </p:sp>
       <p:sp>
         <p:nvSpPr>
-          <p:cNvPr id="21" name="Shape 17"/>
+          <p:cNvPr id="22" name="Shape 17"/>
           <p:cNvSpPr/>
           <p:nvPr/>
         </p:nvSpPr>
@@ -27882,7 +27938,7 @@
       </p:sp>
       <p:graphicFrame>
         <p:nvGraphicFramePr>
-          <p:cNvPr id="22" name="Chart 2" descr=""/>
+          <p:cNvPr id="23" name="Chart 2" descr=""/>
           <p:cNvGraphicFramePr/>
           <p:nvPr/>
         </p:nvGraphicFramePr>
@@ -27898,7 +27954,7 @@
       </p:graphicFrame>
       <p:sp>
         <p:nvSpPr>
-          <p:cNvPr id="23" name="Text 18"/>
+          <p:cNvPr id="24" name="Text 18"/>
           <p:cNvSpPr txBox="1"/>
           <p:nvPr/>
         </p:nvSpPr>
@@ -27937,7 +27993,7 @@
       </p:sp>
       <p:sp>
         <p:nvSpPr>
-          <p:cNvPr id="24" name="Text 19"/>
+          <p:cNvPr id="25" name="Text 19"/>
           <p:cNvSpPr txBox="1"/>
           <p:nvPr/>
         </p:nvSpPr>
@@ -28457,7 +28513,7 @@
       </p:sp>
       <p:sp>
         <p:nvSpPr>
-          <p:cNvPr id="9" name="Shape 7"/>
+          <p:cNvPr id="10" name="Shape 7"/>
           <p:cNvSpPr/>
           <p:nvPr/>
         </p:nvSpPr>
@@ -28477,7 +28533,7 @@
       </p:sp>
       <p:sp>
         <p:nvSpPr>
-          <p:cNvPr id="10" name="Text 8"/>
+          <p:cNvPr id="11" name="Text 8"/>
           <p:cNvSpPr txBox="1"/>
           <p:nvPr/>
         </p:nvSpPr>
@@ -28500,7 +28556,7 @@
               <a:buNone/>
             </a:pPr>
             <a:r>
-              <a:rPr lang="en-US" sz="1400" b="1" dirty="0">
+              <a:rPr lang="en-US" sz="1500" b="1" dirty="0">
                 <a:solidFill>
                   <a:srgbClr val="2D2D2D"/>
                 </a:solidFill>
@@ -28510,13 +28566,13 @@
               </a:rPr>
               <a:t>开篇段落的作用</a:t>
             </a:r>
-            <a:endParaRPr lang="en-US" sz="1400" dirty="0"/>
-          </a:p>
-        </p:txBody>
-      </p:sp>
-      <p:sp>
-        <p:nvSpPr>
-          <p:cNvPr id="11" name="Text 9"/>
+            <a:endParaRPr lang="en-US" sz="1500" dirty="0"/>
+          </a:p>
+        </p:txBody>
+      </p:sp>
+      <p:sp>
+        <p:nvSpPr>
+          <p:cNvPr id="12" name="Text 9"/>
           <p:cNvSpPr txBox="1"/>
           <p:nvPr/>
         </p:nvSpPr>
@@ -28545,7 +28601,7 @@
               <a:buNone/>
             </a:pPr>
             <a:r>
-              <a:rPr lang="en-US" sz="1050" dirty="0">
+              <a:rPr lang="en-US" sz="1350" dirty="0">
                 <a:solidFill>
                   <a:srgbClr val="2D2D2D"/>
                 </a:solidFill>
@@ -28553,15 +28609,15 @@
                 <a:ea typeface="Microsoft YaHei" pitchFamily="34" charset="-122"/>
                 <a:cs typeface="Microsoft YaHei" pitchFamily="34" charset="-120"/>
               </a:rPr>
-              <a:t>文章的开篇段落是吸引读者的关键所在。它就像是一扇门，透过这扇门，读者可以窥见文章的精彩内容。一个引人入胜的开篇能够激发读者的好奇心，促使他们继续阅读下去。这就要求作者在撰写开篇时，要力求创新，用生动有趣的语言，或者提出一个引人深思的问题，来吸引读者的注意力。</a:t>
-            </a:r>
-            <a:endParaRPr lang="en-US" sz="1050" dirty="0"/>
-          </a:p>
-        </p:txBody>
-      </p:sp>
-      <p:sp>
-        <p:nvSpPr>
-          <p:cNvPr id="12" name="Shape 10"/>
+              <a:t>开篇像一扇门，让读者窥见全文的精彩。用生动有趣的语言或引人深思的问题，激发好奇心，促使读者读下去。</a:t>
+            </a:r>
+            <a:endParaRPr lang="en-US" sz="1350" dirty="0"/>
+          </a:p>
+        </p:txBody>
+      </p:sp>
+      <p:sp>
+        <p:nvSpPr>
+          <p:cNvPr id="13" name="Shape 10"/>
           <p:cNvSpPr/>
           <p:nvPr/>
         </p:nvSpPr>
@@ -28581,7 +28637,7 @@
       </p:sp>
       <p:sp>
         <p:nvSpPr>
-          <p:cNvPr id="13" name="Text 11"/>
+          <p:cNvPr id="14" name="Text 11"/>
           <p:cNvSpPr txBox="1"/>
           <p:nvPr/>
         </p:nvSpPr>
@@ -28604,7 +28660,7 @@
               <a:buNone/>
             </a:pPr>
             <a:r>
-              <a:rPr lang="en-US" sz="1400" b="1" dirty="0">
+              <a:rPr lang="en-US" sz="1500" b="1" dirty="0">
                 <a:solidFill>
                   <a:srgbClr val="2D2D2D"/>
                 </a:solidFill>
@@ -28614,13 +28670,13 @@
               </a:rPr>
               <a:t>开篇段落的写作技巧</a:t>
             </a:r>
-            <a:endParaRPr lang="en-US" sz="1400" dirty="0"/>
-          </a:p>
-        </p:txBody>
-      </p:sp>
-      <p:sp>
-        <p:nvSpPr>
-          <p:cNvPr id="14" name="Text 12"/>
+            <a:endParaRPr lang="en-US" sz="1500" dirty="0"/>
+          </a:p>
+        </p:txBody>
+      </p:sp>
+      <p:sp>
+        <p:nvSpPr>
+          <p:cNvPr id="15" name="Text 12"/>
           <p:cNvSpPr txBox="1"/>
           <p:nvPr/>
         </p:nvSpPr>
@@ -28649,7 +28705,7 @@
               <a:buNone/>
             </a:pPr>
             <a:r>
-              <a:rPr lang="en-US" sz="1050" dirty="0">
+              <a:rPr lang="en-US" sz="1350" dirty="0">
                 <a:solidFill>
                   <a:srgbClr val="2D2D2D"/>
                 </a:solidFill>
@@ -28657,15 +28713,15 @@
                 <a:ea typeface="Microsoft YaHei" pitchFamily="34" charset="-122"/>
                 <a:cs typeface="Microsoft YaHei" pitchFamily="34" charset="-120"/>
               </a:rPr>
-              <a:t>在撰写开篇段落时，作者可以采用多种技巧。比如，可以引用一个相关的故事或者案例，让读者产生共鸣；或者提出一个有争议性的观点，引发读者的思考。此外，开篇段落还应该简洁明了，避免冗长的叙述，以免让读者感到疲惫。</a:t>
-            </a:r>
-            <a:endParaRPr lang="en-US" sz="1050" dirty="0"/>
+              <a:t>引用相关故事或案例，引发共鸣；提出有争议性的观点，引发思考；保持简洁明了，避免冗长叙述。</a:t>
+            </a:r>
+            <a:endParaRPr lang="en-US" sz="1350" dirty="0"/>
           </a:p>
         </p:txBody>
       </p:sp>
       <p:pic>
         <p:nvPicPr>
-          <p:cNvPr id="15" name="Image 0" descr="p03_3">    </p:cNvPr>
+          <p:cNvPr id="16" name="Image 0" descr="p03_3">    </p:cNvPr>
           <p:cNvPicPr>
             <a:picLocks noChangeAspect="1"/>
           </p:cNvPicPr>
@@ -28689,7 +28745,7 @@
       </p:pic>
       <p:pic>
         <p:nvPicPr>
-          <p:cNvPr id="16" name="Image 1" descr="p03_4">    </p:cNvPr>
+          <p:cNvPr id="17" name="Image 1" descr="p03_4">    </p:cNvPr>
           <p:cNvPicPr>
             <a:picLocks noChangeAspect="1"/>
           </p:cNvPicPr>
@@ -28982,7 +29038,7 @@
       </p:sp>
       <p:pic>
         <p:nvPicPr>
-          <p:cNvPr id="9" name="Image 0" descr="p04_0">    </p:cNvPr>
+          <p:cNvPr id="10" name="Image 0" descr="p04_0">    </p:cNvPr>
           <p:cNvPicPr>
             <a:picLocks noChangeAspect="1"/>
           </p:cNvPicPr>
@@ -29006,7 +29062,7 @@
       </p:pic>
       <p:pic>
         <p:nvPicPr>
-          <p:cNvPr id="10" name="Image 1" descr="p04_1">    </p:cNvPr>
+          <p:cNvPr id="11" name="Image 1" descr="p04_1">    </p:cNvPr>
           <p:cNvPicPr>
             <a:picLocks noChangeAspect="1"/>
           </p:cNvPicPr>
@@ -29030,7 +29086,7 @@
       </p:pic>
       <p:sp>
         <p:nvSpPr>
-          <p:cNvPr id="11" name="Shape 7"/>
+          <p:cNvPr id="12" name="Shape 7"/>
           <p:cNvSpPr/>
           <p:nvPr/>
         </p:nvSpPr>
@@ -29050,7 +29106,7 @@
       </p:sp>
       <p:sp>
         <p:nvSpPr>
-          <p:cNvPr id="12" name="Text 8"/>
+          <p:cNvPr id="13" name="Text 8"/>
           <p:cNvSpPr txBox="1"/>
           <p:nvPr/>
         </p:nvSpPr>
@@ -29106,7 +29162,7 @@
       </p:sp>
       <p:pic>
         <p:nvPicPr>
-          <p:cNvPr id="13" name="Image 2" descr="p04_2">    </p:cNvPr>
+          <p:cNvPr id="14" name="Image 2" descr="p04_2">    </p:cNvPr>
           <p:cNvPicPr>
             <a:picLocks noChangeAspect="1"/>
           </p:cNvPicPr>
@@ -29130,7 +29186,7 @@
       </p:pic>
       <p:sp>
         <p:nvSpPr>
-          <p:cNvPr id="14" name="Shape 9"/>
+          <p:cNvPr id="15" name="Shape 9"/>
           <p:cNvSpPr/>
           <p:nvPr/>
         </p:nvSpPr>
@@ -29150,7 +29206,7 @@
       </p:sp>
       <p:sp>
         <p:nvSpPr>
-          <p:cNvPr id="15" name="Text 10"/>
+          <p:cNvPr id="16" name="Text 10"/>
           <p:cNvSpPr txBox="1"/>
           <p:nvPr/>
         </p:nvSpPr>
@@ -29173,7 +29229,7 @@
               <a:buNone/>
             </a:pPr>
             <a:r>
-              <a:rPr lang="en-US" sz="1400" b="1" dirty="0">
+              <a:rPr lang="en-US" sz="1500" b="1" dirty="0">
                 <a:solidFill>
                   <a:srgbClr val="2D2D2D"/>
                 </a:solidFill>
@@ -29183,13 +29239,13 @@
               </a:rPr>
               <a:t>研究背景的引入</a:t>
             </a:r>
-            <a:endParaRPr lang="en-US" sz="1400" dirty="0"/>
-          </a:p>
-        </p:txBody>
-      </p:sp>
-      <p:sp>
-        <p:nvSpPr>
-          <p:cNvPr id="16" name="Text 11"/>
+            <a:endParaRPr lang="en-US" sz="1500" dirty="0"/>
+          </a:p>
+        </p:txBody>
+      </p:sp>
+      <p:sp>
+        <p:nvSpPr>
+          <p:cNvPr id="17" name="Text 11"/>
           <p:cNvSpPr txBox="1"/>
           <p:nvPr/>
         </p:nvSpPr>
@@ -29218,7 +29274,7 @@
               <a:buNone/>
             </a:pPr>
             <a:r>
-              <a:rPr lang="en-US" sz="1050" dirty="0">
+              <a:rPr lang="en-US" sz="1350" dirty="0">
                 <a:solidFill>
                   <a:srgbClr val="2D2D2D"/>
                 </a:solidFill>
@@ -29226,15 +29282,15 @@
                 <a:ea typeface="Microsoft YaHei" pitchFamily="34" charset="-122"/>
                 <a:cs typeface="Microsoft YaHei" pitchFamily="34" charset="-120"/>
               </a:rPr>
-              <a:t>在文章的开篇部分，引入研究背景是非常重要的。这有助于读者理解研究的起点和研究的必要性。研究背景的引入应该简洁明了，避免过多的细节，而是要突出研究的核心问题和研究的重要性。</a:t>
-            </a:r>
-            <a:endParaRPr lang="en-US" sz="1050" dirty="0"/>
-          </a:p>
-        </p:txBody>
-      </p:sp>
-      <p:sp>
-        <p:nvSpPr>
-          <p:cNvPr id="17" name="Shape 12"/>
+              <a:t>说明研究的起点与必要性。简洁明了，突出核心问题及其重要性，避免堆砌细节。</a:t>
+            </a:r>
+            <a:endParaRPr lang="en-US" sz="1350" dirty="0"/>
+          </a:p>
+        </p:txBody>
+      </p:sp>
+      <p:sp>
+        <p:nvSpPr>
+          <p:cNvPr id="18" name="Shape 12"/>
           <p:cNvSpPr/>
           <p:nvPr/>
         </p:nvSpPr>
@@ -29254,7 +29310,7 @@
       </p:sp>
       <p:sp>
         <p:nvSpPr>
-          <p:cNvPr id="18" name="Text 13"/>
+          <p:cNvPr id="19" name="Text 13"/>
           <p:cNvSpPr txBox="1"/>
           <p:nvPr/>
         </p:nvSpPr>
@@ -29277,7 +29333,7 @@
               <a:buNone/>
             </a:pPr>
             <a:r>
-              <a:rPr lang="en-US" sz="1400" b="1" dirty="0">
+              <a:rPr lang="en-US" sz="1500" b="1" dirty="0">
                 <a:solidFill>
                   <a:srgbClr val="FFFFFF"/>
                 </a:solidFill>
@@ -29287,13 +29343,13 @@
               </a:rPr>
               <a:t>研究问题的提出</a:t>
             </a:r>
-            <a:endParaRPr lang="en-US" sz="1400" dirty="0"/>
-          </a:p>
-        </p:txBody>
-      </p:sp>
-      <p:sp>
-        <p:nvSpPr>
-          <p:cNvPr id="19" name="Text 14"/>
+            <a:endParaRPr lang="en-US" sz="1500" dirty="0"/>
+          </a:p>
+        </p:txBody>
+      </p:sp>
+      <p:sp>
+        <p:nvSpPr>
+          <p:cNvPr id="20" name="Text 14"/>
           <p:cNvSpPr txBox="1"/>
           <p:nvPr/>
         </p:nvSpPr>
@@ -29322,7 +29378,7 @@
               <a:buNone/>
             </a:pPr>
             <a:r>
-              <a:rPr lang="en-US" sz="1050" dirty="0">
+              <a:rPr lang="en-US" sz="1350" dirty="0">
                 <a:solidFill>
                   <a:srgbClr val="FFFFFF"/>
                 </a:solidFill>
@@ -29330,9 +29386,9 @@
                 <a:ea typeface="Microsoft YaHei" pitchFamily="34" charset="-122"/>
                 <a:cs typeface="Microsoft YaHei" pitchFamily="34" charset="-120"/>
               </a:rPr>
-              <a:t>在开篇部分，作者需要明确提出研究的问题或假设。这些问题或假设应该是具体且具有针对性的，能够引导读者理解研究的方向和目的。通过提出明确的研究问题，读者可以更好地跟随作者的思路，理解文章的核心内容。</a:t>
-            </a:r>
-            <a:endParaRPr lang="en-US" sz="1050" dirty="0"/>
+              <a:t>明确提出具体、有针对性的研究问题或假设，引导读者把握研究的方向与目的。</a:t>
+            </a:r>
+            <a:endParaRPr lang="en-US" sz="1350" dirty="0"/>
           </a:p>
         </p:txBody>
       </p:sp>
@@ -29607,7 +29663,7 @@
       </p:sp>
       <p:sp>
         <p:nvSpPr>
-          <p:cNvPr id="9" name="Shape 7"/>
+          <p:cNvPr id="10" name="Shape 7"/>
           <p:cNvSpPr/>
           <p:nvPr/>
         </p:nvSpPr>
@@ -29627,7 +29683,7 @@
       </p:sp>
       <p:sp>
         <p:nvSpPr>
-          <p:cNvPr id="10" name="Text 8"/>
+          <p:cNvPr id="11" name="Text 8"/>
           <p:cNvSpPr txBox="1"/>
           <p:nvPr/>
         </p:nvSpPr>
@@ -29666,7 +29722,7 @@
       </p:sp>
       <p:sp>
         <p:nvSpPr>
-          <p:cNvPr id="11" name="Text 9"/>
+          <p:cNvPr id="12" name="Text 9"/>
           <p:cNvSpPr txBox="1"/>
           <p:nvPr/>
         </p:nvSpPr>
@@ -29689,7 +29745,7 @@
               <a:buNone/>
             </a:pPr>
             <a:r>
-              <a:rPr lang="en-US" sz="1800" b="1" dirty="0">
+              <a:rPr lang="en-US" sz="1900" b="1" dirty="0">
                 <a:solidFill>
                   <a:srgbClr val="2D2D2D"/>
                 </a:solidFill>
@@ -29699,13 +29755,13 @@
               </a:rPr>
               <a:t>研究创新性的体现</a:t>
             </a:r>
-            <a:endParaRPr lang="en-US" sz="1800" dirty="0"/>
-          </a:p>
-        </p:txBody>
-      </p:sp>
-      <p:sp>
-        <p:nvSpPr>
-          <p:cNvPr id="12" name="Text 10"/>
+            <a:endParaRPr lang="en-US" sz="1900" dirty="0"/>
+          </a:p>
+        </p:txBody>
+      </p:sp>
+      <p:sp>
+        <p:nvSpPr>
+          <p:cNvPr id="13" name="Text 10"/>
           <p:cNvSpPr txBox="1"/>
           <p:nvPr/>
         </p:nvSpPr>
@@ -29734,7 +29790,7 @@
               <a:buNone/>
             </a:pPr>
             <a:r>
-              <a:rPr lang="en-US" sz="1250" dirty="0">
+              <a:rPr lang="en-US" sz="1400" dirty="0">
                 <a:solidFill>
                   <a:srgbClr val="2D2D2D"/>
                 </a:solidFill>
@@ -29742,15 +29798,15 @@
                 <a:ea typeface="Microsoft YaHei" pitchFamily="34" charset="-122"/>
                 <a:cs typeface="Microsoft YaHei" pitchFamily="34" charset="-120"/>
               </a:rPr>
-              <a:t>在文章的开篇部分，作者需要展示研究的创新性或独特视角。这可以通过对比已有研究，指出本研究的新颖之处，或者提出新的理论观点来实现。展示研究的创新性有助于增强文章的学术价值，吸引读者的关注。</a:t>
-            </a:r>
-            <a:endParaRPr lang="en-US" sz="1250" dirty="0"/>
-          </a:p>
-        </p:txBody>
-      </p:sp>
-      <p:sp>
-        <p:nvSpPr>
-          <p:cNvPr id="13" name="Shape 11"/>
+              <a:t>对比已有研究，指出本研究的新颖之处，或提出新的理论观点——增强文章的学术价值，吸引读者关注。</a:t>
+            </a:r>
+            <a:endParaRPr lang="en-US" sz="1400" dirty="0"/>
+          </a:p>
+        </p:txBody>
+      </p:sp>
+      <p:sp>
+        <p:nvSpPr>
+          <p:cNvPr id="14" name="Shape 11"/>
           <p:cNvSpPr/>
           <p:nvPr/>
         </p:nvSpPr>
@@ -29770,7 +29826,7 @@
       </p:sp>
       <p:sp>
         <p:nvSpPr>
-          <p:cNvPr id="14" name="Text 12"/>
+          <p:cNvPr id="15" name="Text 12"/>
           <p:cNvSpPr txBox="1"/>
           <p:nvPr/>
         </p:nvSpPr>
@@ -29809,7 +29865,7 @@
       </p:sp>
       <p:sp>
         <p:nvSpPr>
-          <p:cNvPr id="15" name="Text 13"/>
+          <p:cNvPr id="16" name="Text 13"/>
           <p:cNvSpPr txBox="1"/>
           <p:nvPr/>
         </p:nvSpPr>
@@ -29832,7 +29888,7 @@
               <a:buNone/>
             </a:pPr>
             <a:r>
-              <a:rPr lang="en-US" sz="1800" b="1" dirty="0">
+              <a:rPr lang="en-US" sz="1900" b="1" dirty="0">
                 <a:solidFill>
                   <a:srgbClr val="FFFFFF"/>
                 </a:solidFill>
@@ -29842,13 +29898,13 @@
               </a:rPr>
               <a:t>研究独特贡献的强调</a:t>
             </a:r>
-            <a:endParaRPr lang="en-US" sz="1800" dirty="0"/>
-          </a:p>
-        </p:txBody>
-      </p:sp>
-      <p:sp>
-        <p:nvSpPr>
-          <p:cNvPr id="16" name="Text 14"/>
+            <a:endParaRPr lang="en-US" sz="1900" dirty="0"/>
+          </a:p>
+        </p:txBody>
+      </p:sp>
+      <p:sp>
+        <p:nvSpPr>
+          <p:cNvPr id="17" name="Text 14"/>
           <p:cNvSpPr txBox="1"/>
           <p:nvPr/>
         </p:nvSpPr>
@@ -29877,7 +29933,7 @@
               <a:buNone/>
             </a:pPr>
             <a:r>
-              <a:rPr lang="en-US" sz="1250" dirty="0">
+              <a:rPr lang="en-US" sz="1400" dirty="0">
                 <a:solidFill>
                   <a:srgbClr val="FFFFFF"/>
                 </a:solidFill>
@@ -29885,9 +29941,9 @@
                 <a:ea typeface="Microsoft YaHei" pitchFamily="34" charset="-122"/>
                 <a:cs typeface="Microsoft YaHei" pitchFamily="34" charset="-120"/>
               </a:rPr>
-              <a:t>强调研究的独特贡献是开篇部分的重要任务。作者应该明确指出本研究如何填补学术空白，或者如何解决实际问题。这样不仅能够体现研究的价值，还能够激发读者的阅读兴趣。</a:t>
-            </a:r>
-            <a:endParaRPr lang="en-US" sz="1250" dirty="0"/>
+              <a:t>明确指出本研究如何填补学术空白，或如何解决实际问题——既体现研究价值，也激发阅读兴趣。</a:t>
+            </a:r>
+            <a:endParaRPr lang="en-US" sz="1400" dirty="0"/>
           </a:p>
         </p:txBody>
       </p:sp>
@@ -30162,7 +30218,7 @@
       </p:sp>
       <p:sp>
         <p:nvSpPr>
-          <p:cNvPr id="9" name="Shape 7"/>
+          <p:cNvPr id="10" name="Shape 7"/>
           <p:cNvSpPr/>
           <p:nvPr/>
         </p:nvSpPr>
@@ -30187,7 +30243,7 @@
       </p:sp>
       <p:pic>
         <p:nvPicPr>
-          <p:cNvPr id="10" name="Image 0" descr="p06_4">    </p:cNvPr>
+          <p:cNvPr id="11" name="Image 0" descr="p06_4">    </p:cNvPr>
           <p:cNvPicPr>
             <a:picLocks noChangeAspect="1"/>
           </p:cNvPicPr>
@@ -30211,7 +30267,7 @@
       </p:pic>
       <p:sp>
         <p:nvSpPr>
-          <p:cNvPr id="11" name="Shape 8"/>
+          <p:cNvPr id="12" name="Shape 8"/>
           <p:cNvSpPr/>
           <p:nvPr/>
         </p:nvSpPr>
@@ -30231,7 +30287,7 @@
       </p:sp>
       <p:sp>
         <p:nvSpPr>
-          <p:cNvPr id="12" name="Text 9"/>
+          <p:cNvPr id="13" name="Text 9"/>
           <p:cNvSpPr txBox="1"/>
           <p:nvPr/>
         </p:nvSpPr>
@@ -30254,7 +30310,7 @@
               <a:buNone/>
             </a:pPr>
             <a:r>
-              <a:rPr lang="en-US" sz="1400" b="1" dirty="0">
+              <a:rPr lang="en-US" sz="1500" b="1" dirty="0">
                 <a:solidFill>
                   <a:srgbClr val="2D2D2D"/>
                 </a:solidFill>
@@ -30264,13 +30320,13 @@
               </a:rPr>
               <a:t>概述文章的主要内容</a:t>
             </a:r>
-            <a:endParaRPr lang="en-US" sz="1400" dirty="0"/>
-          </a:p>
-        </p:txBody>
-      </p:sp>
-      <p:sp>
-        <p:nvSpPr>
-          <p:cNvPr id="13" name="Text 10"/>
+            <a:endParaRPr lang="en-US" sz="1500" dirty="0"/>
+          </a:p>
+        </p:txBody>
+      </p:sp>
+      <p:sp>
+        <p:nvSpPr>
+          <p:cNvPr id="14" name="Text 10"/>
           <p:cNvSpPr txBox="1"/>
           <p:nvPr/>
         </p:nvSpPr>
@@ -30299,7 +30355,7 @@
               <a:buNone/>
             </a:pPr>
             <a:r>
-              <a:rPr lang="en-US" sz="1100" dirty="0">
+              <a:rPr lang="en-US" sz="1350" dirty="0">
                 <a:solidFill>
                   <a:srgbClr val="2D2D2D"/>
                 </a:solidFill>
@@ -30307,15 +30363,15 @@
                 <a:ea typeface="Microsoft YaHei" pitchFamily="34" charset="-122"/>
                 <a:cs typeface="Microsoft YaHei" pitchFamily="34" charset="-120"/>
               </a:rPr>
-              <a:t>在开篇部分，作者应该为读者提供清晰的阅读框架，概述文章的主要内容。这包括介绍文章的研究方法、主要观点和结论。通过概述文章结构，读者可以更好地把握文章的脉络，提高阅读效率。</a:t>
-            </a:r>
-            <a:endParaRPr lang="en-US" sz="1100" dirty="0"/>
-          </a:p>
-        </p:txBody>
-      </p:sp>
-      <p:sp>
-        <p:nvSpPr>
-          <p:cNvPr id="14" name="Shape 11"/>
+              <a:t>简要介绍研究方法、主要观点与结论，帮助读者把握文章脉络、提高阅读效率。</a:t>
+            </a:r>
+            <a:endParaRPr lang="en-US" sz="1350" dirty="0"/>
+          </a:p>
+        </p:txBody>
+      </p:sp>
+      <p:sp>
+        <p:nvSpPr>
+          <p:cNvPr id="15" name="Shape 11"/>
           <p:cNvSpPr/>
           <p:nvPr/>
         </p:nvSpPr>
@@ -30335,7 +30391,7 @@
       </p:sp>
       <p:sp>
         <p:nvSpPr>
-          <p:cNvPr id="15" name="Text 12"/>
+          <p:cNvPr id="16" name="Text 12"/>
           <p:cNvSpPr txBox="1"/>
           <p:nvPr/>
         </p:nvSpPr>
@@ -30358,7 +30414,7 @@
               <a:buNone/>
             </a:pPr>
             <a:r>
-              <a:rPr lang="en-US" sz="1400" b="1" dirty="0">
+              <a:rPr lang="en-US" sz="1500" b="1" dirty="0">
                 <a:solidFill>
                   <a:srgbClr val="2D2D2D"/>
                 </a:solidFill>
@@ -30368,13 +30424,13 @@
               </a:rPr>
               <a:t>引导读者进入核心内容</a:t>
             </a:r>
-            <a:endParaRPr lang="en-US" sz="1400" dirty="0"/>
-          </a:p>
-        </p:txBody>
-      </p:sp>
-      <p:sp>
-        <p:nvSpPr>
-          <p:cNvPr id="16" name="Text 13"/>
+            <a:endParaRPr lang="en-US" sz="1500" dirty="0"/>
+          </a:p>
+        </p:txBody>
+      </p:sp>
+      <p:sp>
+        <p:nvSpPr>
+          <p:cNvPr id="17" name="Text 13"/>
           <p:cNvSpPr txBox="1"/>
           <p:nvPr/>
         </p:nvSpPr>
@@ -30403,7 +30459,7 @@
               <a:buNone/>
             </a:pPr>
             <a:r>
-              <a:rPr lang="en-US" sz="1100" dirty="0">
+              <a:rPr lang="en-US" sz="1350" dirty="0">
                 <a:solidFill>
                   <a:srgbClr val="2D2D2D"/>
                 </a:solidFill>
@@ -30411,9 +30467,9 @@
                 <a:ea typeface="Microsoft YaHei" pitchFamily="34" charset="-122"/>
                 <a:cs typeface="Microsoft YaHei" pitchFamily="34" charset="-120"/>
               </a:rPr>
-              <a:t>开篇部分不仅要提供阅读框架，还要引导读者进入文章的核心内容。这可以通过提出问题、设置悬念或者引用相关研究来实现。通过巧妙地引导，读者可以更加投入地阅读文章，理解作者的意图。</a:t>
-            </a:r>
-            <a:endParaRPr lang="en-US" sz="1100" dirty="0"/>
+              <a:t>通过提出问题、设置悬念或引用相关研究，把读者带入文章的核心内容。</a:t>
+            </a:r>
+            <a:endParaRPr lang="en-US" sz="1350" dirty="0"/>
           </a:p>
         </p:txBody>
       </p:sp>
@@ -31338,7 +31394,7 @@
       </p:sp>
       <p:sp>
         <p:nvSpPr>
-          <p:cNvPr id="9" name="Shape 7"/>
+          <p:cNvPr id="10" name="Shape 7"/>
           <p:cNvSpPr/>
           <p:nvPr/>
         </p:nvSpPr>
@@ -31358,7 +31414,7 @@
       </p:sp>
       <p:sp>
         <p:nvSpPr>
-          <p:cNvPr id="10" name="Text 8"/>
+          <p:cNvPr id="11" name="Text 8"/>
           <p:cNvSpPr txBox="1"/>
           <p:nvPr/>
         </p:nvSpPr>
@@ -31397,7 +31453,7 @@
       </p:sp>
       <p:sp>
         <p:nvSpPr>
-          <p:cNvPr id="11" name="Text 9"/>
+          <p:cNvPr id="12" name="Text 9"/>
           <p:cNvSpPr txBox="1"/>
           <p:nvPr/>
         </p:nvSpPr>
@@ -31436,7 +31492,7 @@
       </p:sp>
       <p:sp>
         <p:nvSpPr>
-          <p:cNvPr id="12" name="Shape 10"/>
+          <p:cNvPr id="13" name="Shape 10"/>
           <p:cNvSpPr/>
           <p:nvPr/>
         </p:nvSpPr>
@@ -31456,7 +31512,7 @@
       </p:sp>
       <p:sp>
         <p:nvSpPr>
-          <p:cNvPr id="13" name="Text 11"/>
+          <p:cNvPr id="14" name="Text 11"/>
           <p:cNvSpPr txBox="1"/>
           <p:nvPr/>
         </p:nvSpPr>
@@ -31482,7 +31538,7 @@
               <a:buNone/>
             </a:pPr>
             <a:r>
-              <a:rPr lang="en-US" sz="1200" dirty="0">
+              <a:rPr lang="en-US" sz="1450" dirty="0">
                 <a:solidFill>
                   <a:srgbClr val="2D2D2D"/>
                 </a:solidFill>
@@ -31490,15 +31546,15 @@
                 <a:ea typeface="Microsoft YaHei" pitchFamily="34" charset="-122"/>
                 <a:cs typeface="Microsoft YaHei" pitchFamily="34" charset="-120"/>
               </a:rPr>
-              <a:t>为了提升文章的吸引力，作者需要重新审视开篇段落。这包括检查语言是否生动有趣，是否能够激发读者的好奇心。如果开篇段落过于平淡，作者可以考虑增加一些生动的案例、引用或者提出具有争议性的问题。</a:t>
-            </a:r>
-            <a:endParaRPr lang="en-US" sz="1200" dirty="0"/>
-          </a:p>
-        </p:txBody>
-      </p:sp>
-      <p:sp>
-        <p:nvSpPr>
-          <p:cNvPr id="14" name="Shape 12"/>
+              <a:t>检查语言是否生动有趣、能否激发好奇心。若开篇过于平淡，可加入生动的案例、引用或具有争议性的问题。</a:t>
+            </a:r>
+            <a:endParaRPr lang="en-US" sz="1450" dirty="0"/>
+          </a:p>
+        </p:txBody>
+      </p:sp>
+      <p:sp>
+        <p:nvSpPr>
+          <p:cNvPr id="15" name="Shape 12"/>
           <p:cNvSpPr/>
           <p:nvPr/>
         </p:nvSpPr>
@@ -31518,7 +31574,7 @@
       </p:sp>
       <p:sp>
         <p:nvSpPr>
-          <p:cNvPr id="15" name="Text 13"/>
+          <p:cNvPr id="16" name="Text 13"/>
           <p:cNvSpPr txBox="1"/>
           <p:nvPr/>
         </p:nvSpPr>
@@ -31557,7 +31613,7 @@
       </p:sp>
       <p:sp>
         <p:nvSpPr>
-          <p:cNvPr id="16" name="Text 14"/>
+          <p:cNvPr id="17" name="Text 14"/>
           <p:cNvSpPr txBox="1"/>
           <p:nvPr/>
         </p:nvSpPr>
@@ -31596,7 +31652,7 @@
       </p:sp>
       <p:sp>
         <p:nvSpPr>
-          <p:cNvPr id="17" name="Shape 15"/>
+          <p:cNvPr id="18" name="Shape 15"/>
           <p:cNvSpPr/>
           <p:nvPr/>
         </p:nvSpPr>
@@ -31616,7 +31672,7 @@
       </p:sp>
       <p:sp>
         <p:nvSpPr>
-          <p:cNvPr id="18" name="Text 16"/>
+          <p:cNvPr id="19" name="Text 16"/>
           <p:cNvSpPr txBox="1"/>
           <p:nvPr/>
         </p:nvSpPr>
@@ -31642,7 +31698,7 @@
               <a:buNone/>
             </a:pPr>
             <a:r>
-              <a:rPr lang="en-US" sz="1200" dirty="0">
+              <a:rPr lang="en-US" sz="1450" dirty="0">
                 <a:solidFill>
                   <a:srgbClr val="2D2D2D"/>
                 </a:solidFill>
@@ -31650,9 +31706,9 @@
                 <a:ea typeface="Microsoft YaHei" pitchFamily="34" charset="-122"/>
                 <a:cs typeface="Microsoft YaHei" pitchFamily="34" charset="-120"/>
               </a:rPr>
-              <a:t>在修改开篇时，作者可以增加生动语言，使文章更具吸引力。同时，提出具有争议性的问题也是一个有效的方法。这样的问题能够引发读者的思考，激发他们的阅读兴趣。</a:t>
-            </a:r>
-            <a:endParaRPr lang="en-US" sz="1200" dirty="0"/>
+              <a:t>生动的语言让文章更具吸引力；具有争议性的问题引发读者思考，激发阅读兴趣。</a:t>
+            </a:r>
+            <a:endParaRPr lang="en-US" sz="1450" dirty="0"/>
           </a:p>
         </p:txBody>
       </p:sp>

</xml_diff>